<commit_message>
Present CiteAudit as a standalone project
Remove group name and team references from the README, docs, scripts and slides.
Move docs/team to docs/notes and drop the task-split document.
</commit_message>
<xml_diff>
--- a/slides/week2_progress.pptx
+++ b/slides/week2_progress.pptx
@@ -4,14 +4,11 @@
   <p:sldMasterIdLst>
     <p:sldMasterId id="2147483648" r:id="rId1"/>
   </p:sldMasterIdLst>
-  <p:notesMasterIdLst>
-    <p:notesMasterId r:id="rId4"/>
-  </p:notesMasterIdLst>
   <p:sldIdLst>
-    <p:sldId id="256" r:id="rId2"/>
-    <p:sldId id="257" r:id="rId3"/>
+    <p:sldId id="256" r:id="rId7"/>
+    <p:sldId id="257" r:id="rId9"/>
   </p:sldIdLst>
-  <p:sldSz cx="12192000" cy="6858000"/>
+  <p:sldSz cx="12192000" cy="6858000" type="screen4x3"/>
   <p:notesSz cx="6858000" cy="9144000"/>
   <p:defaultTextStyle>
     <a:defPPr>
@@ -108,27 +105,11 @@
       </a:defRPr>
     </a:lvl9pPr>
   </p:defaultTextStyle>
-  <p:extLst>
-    <p:ext uri="{EFAFB233-063F-42B5-8137-9DF3F51BA10A}">
-      <p15:sldGuideLst xmlns:p15="http://schemas.microsoft.com/office/powerpoint/2012/main">
-        <p15:guide id="1" orient="horz" pos="2160">
-          <p15:clr>
-            <a:srgbClr val="A4A3A4"/>
-          </p15:clr>
-        </p15:guide>
-        <p15:guide id="2" pos="2880">
-          <p15:clr>
-            <a:srgbClr val="A4A3A4"/>
-          </p15:clr>
-        </p15:guide>
-      </p15:sldGuideLst>
-    </p:ext>
-  </p:extLst>
 </p:presentation>
 </file>
 
 <file path=ppt/notesMasters/notesMaster1.xml><?xml version="1.0" encoding="utf-8"?>
-<p:notesMaster xmlns:a="http://schemas.openxmlformats.org/drawingml/2006/main" xmlns:r="http://schemas.openxmlformats.org/officeDocument/2006/relationships" xmlns:p="http://schemas.openxmlformats.org/presentationml/2006/main">
+<p:notesMaster xmlns:a="http://schemas.openxmlformats.org/drawingml/2006/main" xmlns:p="http://schemas.openxmlformats.org/presentationml/2006/main" xmlns:r="http://schemas.openxmlformats.org/officeDocument/2006/relationships">
   <p:cSld>
     <p:bg>
       <p:bgRef idx="1001">
@@ -149,16 +130,241 @@
           <a:chExt cx="0" cy="0"/>
         </a:xfrm>
       </p:grpSpPr>
+      <p:sp>
+        <p:nvSpPr>
+          <p:cNvPr id="2" name="Header Placeholder 1"/>
+          <p:cNvSpPr>
+            <a:spLocks noGrp="1"/>
+          </p:cNvSpPr>
+          <p:nvPr>
+            <p:ph type="hdr" sz="quarter"/>
+          </p:nvPr>
+        </p:nvSpPr>
+        <p:spPr>
+          <a:xfrm>
+            <a:off x="0" y="0"/>
+            <a:ext cx="2971800" cy="457200"/>
+          </a:xfrm>
+          <a:prstGeom prst="rect">
+            <a:avLst/>
+          </a:prstGeom>
+        </p:spPr>
+        <p:txBody>
+          <a:bodyPr vert="horz" lIns="91440" tIns="45720" rIns="91440" bIns="45720" rtlCol="0"/>
+          <a:lstStyle>
+            <a:lvl1pPr algn="l">
+              <a:defRPr sz="1200"/>
+            </a:lvl1pPr>
+          </a:lstStyle>
+          <a:p>
+            <a:endParaRPr lang="en-US"/>
+          </a:p>
+        </p:txBody>
+      </p:sp>
+      <p:sp>
+        <p:nvSpPr>
+          <p:cNvPr id="3" name="Date Placeholder 2"/>
+          <p:cNvSpPr>
+            <a:spLocks noGrp="1"/>
+          </p:cNvSpPr>
+          <p:nvPr>
+            <p:ph type="dt" idx="1"/>
+          </p:nvPr>
+        </p:nvSpPr>
+        <p:spPr>
+          <a:xfrm>
+            <a:off x="3884613" y="0"/>
+            <a:ext cx="2971800" cy="457200"/>
+          </a:xfrm>
+          <a:prstGeom prst="rect">
+            <a:avLst/>
+          </a:prstGeom>
+        </p:spPr>
+        <p:txBody>
+          <a:bodyPr vert="horz" lIns="91440" tIns="45720" rIns="91440" bIns="45720" rtlCol="0"/>
+          <a:lstStyle>
+            <a:lvl1pPr algn="r">
+              <a:defRPr sz="1200"/>
+            </a:lvl1pPr>
+          </a:lstStyle>
+          <a:p>
+            <a:fld id="{0F89C1C7-3DCD-1040-A9CF-14679D8B5DDD}" type="datetimeFigureOut">
+              <a:rPr lang="en-US" smtClean="0"/>
+              <a:t>10/17/16</a:t>
+            </a:fld>
+            <a:endParaRPr lang="en-US"/>
+          </a:p>
+        </p:txBody>
+      </p:sp>
+      <p:sp>
+        <p:nvSpPr>
+          <p:cNvPr id="4" name="Slide Image Placeholder 3"/>
+          <p:cNvSpPr>
+            <a:spLocks noGrp="1" noRot="1" noChangeAspect="1"/>
+          </p:cNvSpPr>
+          <p:nvPr>
+            <p:ph type="sldImg" idx="2"/>
+          </p:nvPr>
+        </p:nvSpPr>
+        <p:spPr>
+          <a:xfrm>
+            <a:off x="1143000" y="685800"/>
+            <a:ext cx="4572000" cy="3429000"/>
+          </a:xfrm>
+          <a:prstGeom prst="rect">
+            <a:avLst/>
+          </a:prstGeom>
+          <a:noFill/>
+          <a:ln w="12700">
+            <a:solidFill>
+              <a:prstClr val="black"/>
+            </a:solidFill>
+          </a:ln>
+        </p:spPr>
+        <p:txBody>
+          <a:bodyPr vert="horz" lIns="91440" tIns="45720" rIns="91440" bIns="45720" rtlCol="0" anchor="ctr"/>
+          <a:lstStyle/>
+          <a:p>
+            <a:endParaRPr lang="en-US"/>
+          </a:p>
+        </p:txBody>
+      </p:sp>
+      <p:sp>
+        <p:nvSpPr>
+          <p:cNvPr id="5" name="Notes Placeholder 4"/>
+          <p:cNvSpPr>
+            <a:spLocks noGrp="1"/>
+          </p:cNvSpPr>
+          <p:nvPr>
+            <p:ph type="body" sz="quarter" idx="3"/>
+          </p:nvPr>
+        </p:nvSpPr>
+        <p:spPr>
+          <a:xfrm>
+            <a:off x="685800" y="4343400"/>
+            <a:ext cx="5486400" cy="4114800"/>
+          </a:xfrm>
+          <a:prstGeom prst="rect">
+            <a:avLst/>
+          </a:prstGeom>
+        </p:spPr>
+        <p:txBody>
+          <a:bodyPr vert="horz" lIns="91440" tIns="45720" rIns="91440" bIns="45720" rtlCol="0"/>
+          <a:lstStyle/>
+          <a:p>
+            <a:pPr lvl="0"/>
+            <a:r>
+              <a:rPr lang="en-US" smtClean="0"/>
+              <a:t>Click to edit Master text styles</a:t>
+            </a:r>
+          </a:p>
+          <a:p>
+            <a:pPr lvl="1"/>
+            <a:r>
+              <a:rPr lang="en-US" smtClean="0"/>
+              <a:t>Second level</a:t>
+            </a:r>
+          </a:p>
+          <a:p>
+            <a:pPr lvl="2"/>
+            <a:r>
+              <a:rPr lang="en-US" smtClean="0"/>
+              <a:t>Third level</a:t>
+            </a:r>
+          </a:p>
+          <a:p>
+            <a:pPr lvl="3"/>
+            <a:r>
+              <a:rPr lang="en-US" smtClean="0"/>
+              <a:t>Fourth level</a:t>
+            </a:r>
+          </a:p>
+          <a:p>
+            <a:pPr lvl="4"/>
+            <a:r>
+              <a:rPr lang="en-US" smtClean="0"/>
+              <a:t>Fifth level</a:t>
+            </a:r>
+            <a:endParaRPr lang="en-US"/>
+          </a:p>
+        </p:txBody>
+      </p:sp>
+      <p:sp>
+        <p:nvSpPr>
+          <p:cNvPr id="6" name="Footer Placeholder 5"/>
+          <p:cNvSpPr>
+            <a:spLocks noGrp="1"/>
+          </p:cNvSpPr>
+          <p:nvPr>
+            <p:ph type="ftr" sz="quarter" idx="4"/>
+          </p:nvPr>
+        </p:nvSpPr>
+        <p:spPr>
+          <a:xfrm>
+            <a:off x="0" y="8685213"/>
+            <a:ext cx="2971800" cy="457200"/>
+          </a:xfrm>
+          <a:prstGeom prst="rect">
+            <a:avLst/>
+          </a:prstGeom>
+        </p:spPr>
+        <p:txBody>
+          <a:bodyPr vert="horz" lIns="91440" tIns="45720" rIns="91440" bIns="45720" rtlCol="0" anchor="b"/>
+          <a:lstStyle>
+            <a:lvl1pPr algn="l">
+              <a:defRPr sz="1200"/>
+            </a:lvl1pPr>
+          </a:lstStyle>
+          <a:p>
+            <a:endParaRPr lang="en-US"/>
+          </a:p>
+        </p:txBody>
+      </p:sp>
+      <p:sp>
+        <p:nvSpPr>
+          <p:cNvPr id="7" name="Slide Number Placeholder 6"/>
+          <p:cNvSpPr>
+            <a:spLocks noGrp="1"/>
+          </p:cNvSpPr>
+          <p:nvPr>
+            <p:ph type="sldNum" sz="quarter" idx="5"/>
+          </p:nvPr>
+        </p:nvSpPr>
+        <p:spPr>
+          <a:xfrm>
+            <a:off x="3884613" y="8685213"/>
+            <a:ext cx="2971800" cy="457200"/>
+          </a:xfrm>
+          <a:prstGeom prst="rect">
+            <a:avLst/>
+          </a:prstGeom>
+        </p:spPr>
+        <p:txBody>
+          <a:bodyPr vert="horz" lIns="91440" tIns="45720" rIns="91440" bIns="45720" rtlCol="0" anchor="b"/>
+          <a:lstStyle>
+            <a:lvl1pPr algn="r">
+              <a:defRPr sz="1200"/>
+            </a:lvl1pPr>
+          </a:lstStyle>
+          <a:p>
+            <a:fld id="{BB5E49A5-4136-284D-997B-48E1D791AD67}" type="slidenum">
+              <a:rPr lang="en-US" smtClean="0"/>
+              <a:t>‹#›</a:t>
+            </a:fld>
+            <a:endParaRPr lang="en-US"/>
+          </a:p>
+        </p:txBody>
+      </p:sp>
     </p:spTree>
     <p:extLst>
       <p:ext uri="{BB962C8B-B14F-4D97-AF65-F5344CB8AC3E}">
-        <p14:creationId xmlns:p14="http://schemas.microsoft.com/office/powerpoint/2010/main" val="1453549392"/>
+        <p14:creationId xmlns:p14="http://schemas.microsoft.com/office/powerpoint/2010/main" val="2623252185"/>
       </p:ext>
     </p:extLst>
   </p:cSld>
   <p:clrMap bg1="lt1" tx1="dk1" bg2="lt2" tx2="dk2" accent1="accent1" accent2="accent2" accent3="accent3" accent4="accent4" accent5="accent5" accent6="accent6" hlink="hlink" folHlink="folHlink"/>
   <p:notesStyle>
-    <a:lvl1pPr marL="0" algn="l" defTabSz="914400" rtl="0" eaLnBrk="1" latinLnBrk="0" hangingPunct="1">
+    <a:lvl1pPr marL="0" algn="l" defTabSz="457200" rtl="0" eaLnBrk="1" latinLnBrk="0" hangingPunct="1">
       <a:defRPr sz="1200" kern="1200">
         <a:solidFill>
           <a:schemeClr val="tx1"/>
@@ -168,7 +374,7 @@
         <a:cs typeface="+mn-cs"/>
       </a:defRPr>
     </a:lvl1pPr>
-    <a:lvl2pPr marL="457200" algn="l" defTabSz="914400" rtl="0" eaLnBrk="1" latinLnBrk="0" hangingPunct="1">
+    <a:lvl2pPr marL="457200" algn="l" defTabSz="457200" rtl="0" eaLnBrk="1" latinLnBrk="0" hangingPunct="1">
       <a:defRPr sz="1200" kern="1200">
         <a:solidFill>
           <a:schemeClr val="tx1"/>
@@ -178,7 +384,7 @@
         <a:cs typeface="+mn-cs"/>
       </a:defRPr>
     </a:lvl2pPr>
-    <a:lvl3pPr marL="914400" algn="l" defTabSz="914400" rtl="0" eaLnBrk="1" latinLnBrk="0" hangingPunct="1">
+    <a:lvl3pPr marL="914400" algn="l" defTabSz="457200" rtl="0" eaLnBrk="1" latinLnBrk="0" hangingPunct="1">
       <a:defRPr sz="1200" kern="1200">
         <a:solidFill>
           <a:schemeClr val="tx1"/>
@@ -188,7 +394,7 @@
         <a:cs typeface="+mn-cs"/>
       </a:defRPr>
     </a:lvl3pPr>
-    <a:lvl4pPr marL="1371600" algn="l" defTabSz="914400" rtl="0" eaLnBrk="1" latinLnBrk="0" hangingPunct="1">
+    <a:lvl4pPr marL="1371600" algn="l" defTabSz="457200" rtl="0" eaLnBrk="1" latinLnBrk="0" hangingPunct="1">
       <a:defRPr sz="1200" kern="1200">
         <a:solidFill>
           <a:schemeClr val="tx1"/>
@@ -198,7 +404,7 @@
         <a:cs typeface="+mn-cs"/>
       </a:defRPr>
     </a:lvl4pPr>
-    <a:lvl5pPr marL="1828800" algn="l" defTabSz="914400" rtl="0" eaLnBrk="1" latinLnBrk="0" hangingPunct="1">
+    <a:lvl5pPr marL="1828800" algn="l" defTabSz="457200" rtl="0" eaLnBrk="1" latinLnBrk="0" hangingPunct="1">
       <a:defRPr sz="1200" kern="1200">
         <a:solidFill>
           <a:schemeClr val="tx1"/>
@@ -208,7 +414,7 @@
         <a:cs typeface="+mn-cs"/>
       </a:defRPr>
     </a:lvl5pPr>
-    <a:lvl6pPr marL="2286000" algn="l" defTabSz="914400" rtl="0" eaLnBrk="1" latinLnBrk="0" hangingPunct="1">
+    <a:lvl6pPr marL="2286000" algn="l" defTabSz="457200" rtl="0" eaLnBrk="1" latinLnBrk="0" hangingPunct="1">
       <a:defRPr sz="1200" kern="1200">
         <a:solidFill>
           <a:schemeClr val="tx1"/>
@@ -218,7 +424,7 @@
         <a:cs typeface="+mn-cs"/>
       </a:defRPr>
     </a:lvl6pPr>
-    <a:lvl7pPr marL="2743200" algn="l" defTabSz="914400" rtl="0" eaLnBrk="1" latinLnBrk="0" hangingPunct="1">
+    <a:lvl7pPr marL="2743200" algn="l" defTabSz="457200" rtl="0" eaLnBrk="1" latinLnBrk="0" hangingPunct="1">
       <a:defRPr sz="1200" kern="1200">
         <a:solidFill>
           <a:schemeClr val="tx1"/>
@@ -228,7 +434,7 @@
         <a:cs typeface="+mn-cs"/>
       </a:defRPr>
     </a:lvl7pPr>
-    <a:lvl8pPr marL="3200400" algn="l" defTabSz="914400" rtl="0" eaLnBrk="1" latinLnBrk="0" hangingPunct="1">
+    <a:lvl8pPr marL="3200400" algn="l" defTabSz="457200" rtl="0" eaLnBrk="1" latinLnBrk="0" hangingPunct="1">
       <a:defRPr sz="1200" kern="1200">
         <a:solidFill>
           <a:schemeClr val="tx1"/>
@@ -238,7 +444,7 @@
         <a:cs typeface="+mn-cs"/>
       </a:defRPr>
     </a:lvl8pPr>
-    <a:lvl9pPr marL="3657600" algn="l" defTabSz="914400" rtl="0" eaLnBrk="1" latinLnBrk="0" hangingPunct="1">
+    <a:lvl9pPr marL="3657600" algn="l" defTabSz="457200" rtl="0" eaLnBrk="1" latinLnBrk="0" hangingPunct="1">
       <a:defRPr sz="1200" kern="1200">
         <a:solidFill>
           <a:schemeClr val="tx1"/>
@@ -253,7 +459,7 @@
 </file>
 
 <file path=ppt/notesSlides/notesSlide1.xml><?xml version="1.0" encoding="utf-8"?>
-<p:notes xmlns:a="http://schemas.openxmlformats.org/drawingml/2006/main" xmlns:r="http://schemas.openxmlformats.org/officeDocument/2006/relationships" xmlns:p="http://schemas.openxmlformats.org/presentationml/2006/main">
+<p:notes xmlns:a="http://schemas.openxmlformats.org/drawingml/2006/main" xmlns:p="http://schemas.openxmlformats.org/presentationml/2006/main" xmlns:r="http://schemas.openxmlformats.org/officeDocument/2006/relationships">
   <p:cSld>
     <p:spTree>
       <p:nvGrpSpPr>
@@ -273,7 +479,7 @@
         <p:nvSpPr>
           <p:cNvPr id="2" name="Slide Image Placeholder 1"/>
           <p:cNvSpPr>
-            <a:spLocks noGrp="1" noRot="1" noChangeAspect="1"/>
+            <a:spLocks noGrp="1"/>
           </p:cNvSpPr>
           <p:nvPr>
             <p:ph type="sldImg" idx="2"/>
@@ -288,7 +494,7 @@
             <a:spLocks noGrp="1"/>
           </p:cNvSpPr>
           <p:nvPr>
-            <p:ph type="body" sz="quarter" idx="3"/>
+            <p:ph type="body" idx="3" sz="quarter"/>
           </p:nvPr>
         </p:nvSpPr>
         <p:spPr/>
@@ -300,41 +506,31 @@
               <a:t>Start with the problem block, it carries the slide. A citance is a sentence in one paper that cites another. Citation integrity asks whether that sentence represents the cited work accurately. The part that makes it an NLP problem rather than a judgement call is that the verdict has to rest on specific sentences inside the cited article — you cannot answer it from the abstract or the title.</a:t>
             </a:r>
           </a:p>
-          <a:p>
-            <a:endParaRPr/>
-          </a:p>
+          <a:p/>
           <a:p>
             <a:r>
               <a:t>The three numbers on the right are the scale of it. Averaged over the 487 test citances, a citance has 239 candidate sentences drawn from the article it cites, the annotators marked about 2.5 of them as the evidence, and the classifier only ever sees the twenty that retrieval hands it. So retrieval is a hard filter on everything downstream, which is why we went after it first.</a:t>
             </a:r>
           </a:p>
-          <a:p>
-            <a:endParaRPr/>
-          </a:p>
+          <a:p/>
           <a:p>
             <a:r>
               <a:t>The pipeline is three stages and it is the same three stages in both arms: retrieve, rerank, classify. Stage 1 narrows 239 candidate sentences to 60 with BM25. Stage 2 reorders those 60 and keeps the top 20. Stage 3 reads those 20 and emits one of the three labels.</a:t>
             </a:r>
           </a:p>
-          <a:p>
-            <a:endParaRPr/>
-          </a:p>
+          <a:p/>
           <a:p>
             <a:r>
               <a:t>Prior work is Sarol et al. 2024 in Bioinformatics — the blue row. BM25, then MonoT5-base applied zero-shot, then MultiVerS, a Longformer-large model fine-tuned for the three-way label. We reproduced their published retrieval numbers before touching anything: 0.529 Recall@20 against their 0.53, 0.323 MRR against their 0.32.</a:t>
             </a:r>
           </a:p>
-          <a:p>
-            <a:endParaRPr/>
-          </a:p>
+          <a:p/>
           <a:p>
             <a:r>
               <a:t>Our method is the orange row, and the point of the shaded column is that only stage 2 differs. Same citances, same candidate pool, same BM25 settings and depth 60, same metric code, same frozen MultiVerS checkpoint. The reranker becomes a PubMedBERT cross-encoder, fine-tuned on this task's own training articles, scoring each candidate sentence together with one neighbour on each side rather than alone.</a:t>
             </a:r>
           </a:p>
-          <a:p>
-            <a:endParaRPr/>
-          </a:p>
+          <a:p/>
           <a:p>
             <a:r>
               <a:t>Two differentiations worth naming out loud. Supervision: their reranker is a general-domain model transferred zero-shot, ours is trained in domain. And the unit being scored: a lone sentence versus a sentence in context — biomedical evidence sentences frequently need the sentence before them for the referent. Both are also cheaper, not more expensive: 109.5M parameters against 222.9M.</a:t>
@@ -349,7 +545,7 @@
             <a:spLocks noGrp="1"/>
           </p:cNvSpPr>
           <p:nvPr>
-            <p:ph type="sldNum" sz="quarter" idx="5"/>
+            <p:ph type="sldNum" idx="5" sz="quarter"/>
           </p:nvPr>
         </p:nvSpPr>
         <p:spPr/>
@@ -363,7 +559,7 @@
 </file>
 
 <file path=ppt/notesSlides/notesSlide2.xml><?xml version="1.0" encoding="utf-8"?>
-<p:notes xmlns:a="http://schemas.openxmlformats.org/drawingml/2006/main" xmlns:r="http://schemas.openxmlformats.org/officeDocument/2006/relationships" xmlns:p="http://schemas.openxmlformats.org/presentationml/2006/main">
+<p:notes xmlns:a="http://schemas.openxmlformats.org/drawingml/2006/main" xmlns:p="http://schemas.openxmlformats.org/presentationml/2006/main" xmlns:r="http://schemas.openxmlformats.org/officeDocument/2006/relationships">
   <p:cSld>
     <p:spTree>
       <p:nvGrpSpPr>
@@ -383,7 +579,7 @@
         <p:nvSpPr>
           <p:cNvPr id="2" name="Slide Image Placeholder 1"/>
           <p:cNvSpPr>
-            <a:spLocks noGrp="1" noRot="1" noChangeAspect="1"/>
+            <a:spLocks noGrp="1"/>
           </p:cNvSpPr>
           <p:nvPr>
             <p:ph type="sldImg" idx="2"/>
@@ -398,7 +594,7 @@
             <a:spLocks noGrp="1"/>
           </p:cNvSpPr>
           <p:nvPr>
-            <p:ph type="body" sz="quarter" idx="3"/>
+            <p:ph type="body" idx="3" sz="quarter"/>
           </p:nvPr>
         </p:nvSpPr>
         <p:spPr/>
@@ -410,65 +606,49 @@
               <a:t>Take the right-hand box first, because it is chronologically first and it explains why we worked on the reranker at all.</a:t>
             </a:r>
           </a:p>
-          <a:p>
-            <a:endParaRPr/>
-          </a:p>
+          <a:p/>
           <a:p>
             <a:r>
               <a:t>The obvious suspect was the cheap filter. BM25 keeps only 60 of a citance's 239 candidate sentences before anything smart looks at them, and that cut really does throw away 29% of the annotated evidence — BM25's own recall at depth 60 is 0.712, so no reranker working behind it can exceed that. So we removed the filter and let MonoT5 score all 239.</a:t>
             </a:r>
           </a:p>
-          <a:p>
-            <a:endParaRPr/>
-          </a:p>
+          <a:p/>
           <a:p>
             <a:r>
               <a:t>It bought nothing. Recall@20 went 0.529 to 0.541, a paired delta of +0.012 whose interval includes zero, winning on only 10 of 20 articles — a coin flip — and AllGold@20 and MRR both came out flat or slightly negative, all at four times the candidates scored. So the evidence the filter discards is evidence MonoT5 would not have ranked highly anyway. The limit was the reranker, not the filter. That is what sent us to stage 2.</a:t>
             </a:r>
           </a:p>
-          <a:p>
-            <a:endParaRPr/>
-          </a:p>
+          <a:p/>
           <a:p>
             <a:r>
               <a:t>Now the left table, which is the main result. Held-out test Recall@20 goes 0.529 to 0.638, a paired gain of +0.109 plus or minus 0.024, winning on 17 of the 20 test articles. All four metrics move and no interval touches zero. The test split was measured exactly once, after the recipe was frozen on dev.</a:t>
             </a:r>
           </a:p>
-          <a:p>
-            <a:endParaRPr/>
-          </a:p>
+          <a:p/>
           <a:p>
             <a:r>
               <a:t>Read the pattern across the metrics, not just the headline. Recall@20 and AllGold@20 both move about ten points; MRR moves four and wins on only 13 of 20 articles. We capture more evidence and more often capture all of it, but we are only slightly better at putting a correct sentence first. That matches the change we made: the context window helps recognise relevance and slightly hurts top-1 precision. For this pipeline that trade is fine, because the classifier receives the top-20 as a set and does not care about the order.</a:t>
             </a:r>
           </a:p>
-          <a:p>
-            <a:endParaRPr/>
-          </a:p>
+          <a:p/>
           <a:p>
             <a:r>
               <a:t>Cost: 109.5M parameters against 222.9M and 2.2x the throughput, but as configured we use 1.36x the FLOPs. Both numbers are real. We run faster despite more arithmetic because there is no serial decoder step.</a:t>
             </a:r>
           </a:p>
-          <a:p>
-            <a:endParaRPr/>
-          </a:p>
+          <a:p/>
           <a:p>
             <a:r>
               <a:t>The navy line is the finding that caps the slide. Under the released MultiVerS checkpoint the better evidence changes no label — both arms tie at McNemar p = 1.000 — and an oracle with perfect evidence is the worst arm of all. Random evidence does cost 19 to 25 points at p &lt; 0.001, so the classifier is reading its input; it simply cannot exploit anything above the retrieval distribution it was trained on.</a:t>
             </a:r>
           </a:p>
-          <a:p>
-            <a:endParaRPr/>
-          </a:p>
+          <a:p/>
           <a:p>
             <a:r>
               <a:t>Which makes the first remaining item the decisive one. The paper's own gold-evidence row is +0.23 macro-F1 over its top-20 row, but their gold-evidence model was trained on gold evidence. Retraining the classifier on each arm's output is the experiment that decides whether our retrieval gain is worth anything downstream. It needs the CUDA machine: Longformer-large, likely with gradient checkpointing at 8 GB.</a:t>
             </a:r>
           </a:p>
-          <a:p>
-            <a:endParaRPr/>
-          </a:p>
+          <a:p/>
           <a:p>
             <a:r>
               <a:t>The other three are smaller. A quarter of reranker inputs truncate at 192 tokens, so the length sweep has headroom — and our 0.638 is now within 0.074 of BM25's depth-60 ceiling of 0.712, so the filter depth is becoming a live constraint for us even though it was not one for MonoT5. Dynamic padding should cut the FLOPs overhead from 1.36x to 1.06x at no measured speed cost. And both arms must be rerun inside one session for the final table: numbers taken on different dates drifted by 0.012 on dev, which we traced to the environment rather than to our code.</a:t>
@@ -483,7 +663,7 @@
             <a:spLocks noGrp="1"/>
           </p:cNvSpPr>
           <p:nvPr>
-            <p:ph type="sldNum" sz="quarter" idx="5"/>
+            <p:ph type="sldNum" idx="5" sz="quarter"/>
           </p:nvPr>
         </p:nvSpPr>
         <p:spPr/>
@@ -534,9 +714,10 @@
           <a:lstStyle/>
           <a:p>
             <a:r>
-              <a:rPr lang="en-US"/>
+              <a:rPr lang="en-US" smtClean="0"/>
               <a:t>Click to edit Master title style</a:t>
             </a:r>
+            <a:endParaRPr lang="en-US"/>
           </a:p>
         </p:txBody>
       </p:sp>
@@ -652,9 +833,10 @@
           </a:lstStyle>
           <a:p>
             <a:r>
-              <a:rPr lang="en-US"/>
+              <a:rPr lang="en-US" smtClean="0"/>
               <a:t>Click to edit Master subtitle style</a:t>
             </a:r>
+            <a:endParaRPr lang="en-US"/>
           </a:p>
         </p:txBody>
       </p:sp>
@@ -675,7 +857,7 @@
           <a:p>
             <a:fld id="{5BCAD085-E8A6-8845-BD4E-CB4CCA059FC4}" type="datetimeFigureOut">
               <a:rPr lang="en-US" smtClean="0"/>
-              <a:t>10/20/26</a:t>
+              <a:t>1/27/13</a:t>
             </a:fld>
             <a:endParaRPr lang="en-US"/>
           </a:p>
@@ -769,9 +951,10 @@
           <a:lstStyle/>
           <a:p>
             <a:r>
-              <a:rPr lang="en-US"/>
+              <a:rPr lang="en-US" smtClean="0"/>
               <a:t>Click to edit Master title style</a:t>
             </a:r>
+            <a:endParaRPr lang="en-US"/>
           </a:p>
         </p:txBody>
       </p:sp>
@@ -792,37 +975,38 @@
           <a:p>
             <a:pPr lvl="0"/>
             <a:r>
-              <a:rPr lang="en-US"/>
+              <a:rPr lang="en-US" smtClean="0"/>
               <a:t>Click to edit Master text styles</a:t>
             </a:r>
           </a:p>
           <a:p>
             <a:pPr lvl="1"/>
             <a:r>
-              <a:rPr lang="en-US"/>
+              <a:rPr lang="en-US" smtClean="0"/>
               <a:t>Second level</a:t>
             </a:r>
           </a:p>
           <a:p>
             <a:pPr lvl="2"/>
             <a:r>
-              <a:rPr lang="en-US"/>
+              <a:rPr lang="en-US" smtClean="0"/>
               <a:t>Third level</a:t>
             </a:r>
           </a:p>
           <a:p>
             <a:pPr lvl="3"/>
             <a:r>
-              <a:rPr lang="en-US"/>
+              <a:rPr lang="en-US" smtClean="0"/>
               <a:t>Fourth level</a:t>
             </a:r>
           </a:p>
           <a:p>
             <a:pPr lvl="4"/>
             <a:r>
-              <a:rPr lang="en-US"/>
+              <a:rPr lang="en-US" smtClean="0"/>
               <a:t>Fifth level</a:t>
             </a:r>
+            <a:endParaRPr lang="en-US"/>
           </a:p>
         </p:txBody>
       </p:sp>
@@ -843,7 +1027,7 @@
           <a:p>
             <a:fld id="{5BCAD085-E8A6-8845-BD4E-CB4CCA059FC4}" type="datetimeFigureOut">
               <a:rPr lang="en-US" smtClean="0"/>
-              <a:t>10/20/26</a:t>
+              <a:t>1/27/13</a:t>
             </a:fld>
             <a:endParaRPr lang="en-US"/>
           </a:p>
@@ -942,9 +1126,10 @@
           <a:lstStyle/>
           <a:p>
             <a:r>
-              <a:rPr lang="en-US"/>
+              <a:rPr lang="en-US" smtClean="0"/>
               <a:t>Click to edit Master title style</a:t>
             </a:r>
+            <a:endParaRPr lang="en-US"/>
           </a:p>
         </p:txBody>
       </p:sp>
@@ -970,37 +1155,38 @@
           <a:p>
             <a:pPr lvl="0"/>
             <a:r>
-              <a:rPr lang="en-US"/>
+              <a:rPr lang="en-US" smtClean="0"/>
               <a:t>Click to edit Master text styles</a:t>
             </a:r>
           </a:p>
           <a:p>
             <a:pPr lvl="1"/>
             <a:r>
-              <a:rPr lang="en-US"/>
+              <a:rPr lang="en-US" smtClean="0"/>
               <a:t>Second level</a:t>
             </a:r>
           </a:p>
           <a:p>
             <a:pPr lvl="2"/>
             <a:r>
-              <a:rPr lang="en-US"/>
+              <a:rPr lang="en-US" smtClean="0"/>
               <a:t>Third level</a:t>
             </a:r>
           </a:p>
           <a:p>
             <a:pPr lvl="3"/>
             <a:r>
-              <a:rPr lang="en-US"/>
+              <a:rPr lang="en-US" smtClean="0"/>
               <a:t>Fourth level</a:t>
             </a:r>
           </a:p>
           <a:p>
             <a:pPr lvl="4"/>
             <a:r>
-              <a:rPr lang="en-US"/>
+              <a:rPr lang="en-US" smtClean="0"/>
               <a:t>Fifth level</a:t>
             </a:r>
+            <a:endParaRPr lang="en-US"/>
           </a:p>
         </p:txBody>
       </p:sp>
@@ -1021,7 +1207,7 @@
           <a:p>
             <a:fld id="{5BCAD085-E8A6-8845-BD4E-CB4CCA059FC4}" type="datetimeFigureOut">
               <a:rPr lang="en-US" smtClean="0"/>
-              <a:t>10/20/26</a:t>
+              <a:t>1/27/13</a:t>
             </a:fld>
             <a:endParaRPr lang="en-US"/>
           </a:p>
@@ -1115,9 +1301,10 @@
           <a:lstStyle/>
           <a:p>
             <a:r>
-              <a:rPr lang="en-US"/>
+              <a:rPr lang="en-US" smtClean="0"/>
               <a:t>Click to edit Master title style</a:t>
             </a:r>
+            <a:endParaRPr lang="en-US"/>
           </a:p>
         </p:txBody>
       </p:sp>
@@ -1138,37 +1325,38 @@
           <a:p>
             <a:pPr lvl="0"/>
             <a:r>
-              <a:rPr lang="en-US"/>
+              <a:rPr lang="en-US" smtClean="0"/>
               <a:t>Click to edit Master text styles</a:t>
             </a:r>
           </a:p>
           <a:p>
             <a:pPr lvl="1"/>
             <a:r>
-              <a:rPr lang="en-US"/>
+              <a:rPr lang="en-US" smtClean="0"/>
               <a:t>Second level</a:t>
             </a:r>
           </a:p>
           <a:p>
             <a:pPr lvl="2"/>
             <a:r>
-              <a:rPr lang="en-US"/>
+              <a:rPr lang="en-US" smtClean="0"/>
               <a:t>Third level</a:t>
             </a:r>
           </a:p>
           <a:p>
             <a:pPr lvl="3"/>
             <a:r>
-              <a:rPr lang="en-US"/>
+              <a:rPr lang="en-US" smtClean="0"/>
               <a:t>Fourth level</a:t>
             </a:r>
           </a:p>
           <a:p>
             <a:pPr lvl="4"/>
             <a:r>
-              <a:rPr lang="en-US"/>
+              <a:rPr lang="en-US" smtClean="0"/>
               <a:t>Fifth level</a:t>
             </a:r>
+            <a:endParaRPr lang="en-US"/>
           </a:p>
         </p:txBody>
       </p:sp>
@@ -1189,7 +1377,7 @@
           <a:p>
             <a:fld id="{5BCAD085-E8A6-8845-BD4E-CB4CCA059FC4}" type="datetimeFigureOut">
               <a:rPr lang="en-US" smtClean="0"/>
-              <a:t>10/20/26</a:t>
+              <a:t>1/27/13</a:t>
             </a:fld>
             <a:endParaRPr lang="en-US"/>
           </a:p>
@@ -1292,9 +1480,10 @@
           </a:lstStyle>
           <a:p>
             <a:r>
-              <a:rPr lang="en-US"/>
+              <a:rPr lang="en-US" smtClean="0"/>
               <a:t>Click to edit Master title style</a:t>
             </a:r>
+            <a:endParaRPr lang="en-US"/>
           </a:p>
         </p:txBody>
       </p:sp>
@@ -1411,7 +1600,7 @@
           <a:p>
             <a:pPr lvl="0"/>
             <a:r>
-              <a:rPr lang="en-US"/>
+              <a:rPr lang="en-US" smtClean="0"/>
               <a:t>Click to edit Master text styles</a:t>
             </a:r>
           </a:p>
@@ -1434,7 +1623,7 @@
           <a:p>
             <a:fld id="{5BCAD085-E8A6-8845-BD4E-CB4CCA059FC4}" type="datetimeFigureOut">
               <a:rPr lang="en-US" smtClean="0"/>
-              <a:t>10/20/26</a:t>
+              <a:t>1/27/13</a:t>
             </a:fld>
             <a:endParaRPr lang="en-US"/>
           </a:p>
@@ -1528,9 +1717,10 @@
           <a:lstStyle/>
           <a:p>
             <a:r>
-              <a:rPr lang="en-US"/>
+              <a:rPr lang="en-US" smtClean="0"/>
               <a:t>Click to edit Master title style</a:t>
             </a:r>
+            <a:endParaRPr lang="en-US"/>
           </a:p>
         </p:txBody>
       </p:sp>
@@ -1584,37 +1774,38 @@
           <a:p>
             <a:pPr lvl="0"/>
             <a:r>
-              <a:rPr lang="en-US"/>
+              <a:rPr lang="en-US" smtClean="0"/>
               <a:t>Click to edit Master text styles</a:t>
             </a:r>
           </a:p>
           <a:p>
             <a:pPr lvl="1"/>
             <a:r>
-              <a:rPr lang="en-US"/>
+              <a:rPr lang="en-US" smtClean="0"/>
               <a:t>Second level</a:t>
             </a:r>
           </a:p>
           <a:p>
             <a:pPr lvl="2"/>
             <a:r>
-              <a:rPr lang="en-US"/>
+              <a:rPr lang="en-US" smtClean="0"/>
               <a:t>Third level</a:t>
             </a:r>
           </a:p>
           <a:p>
             <a:pPr lvl="3"/>
             <a:r>
-              <a:rPr lang="en-US"/>
+              <a:rPr lang="en-US" smtClean="0"/>
               <a:t>Fourth level</a:t>
             </a:r>
           </a:p>
           <a:p>
             <a:pPr lvl="4"/>
             <a:r>
-              <a:rPr lang="en-US"/>
+              <a:rPr lang="en-US" smtClean="0"/>
               <a:t>Fifth level</a:t>
             </a:r>
+            <a:endParaRPr lang="en-US"/>
           </a:p>
         </p:txBody>
       </p:sp>
@@ -1668,37 +1859,38 @@
           <a:p>
             <a:pPr lvl="0"/>
             <a:r>
-              <a:rPr lang="en-US"/>
+              <a:rPr lang="en-US" smtClean="0"/>
               <a:t>Click to edit Master text styles</a:t>
             </a:r>
           </a:p>
           <a:p>
             <a:pPr lvl="1"/>
             <a:r>
-              <a:rPr lang="en-US"/>
+              <a:rPr lang="en-US" smtClean="0"/>
               <a:t>Second level</a:t>
             </a:r>
           </a:p>
           <a:p>
             <a:pPr lvl="2"/>
             <a:r>
-              <a:rPr lang="en-US"/>
+              <a:rPr lang="en-US" smtClean="0"/>
               <a:t>Third level</a:t>
             </a:r>
           </a:p>
           <a:p>
             <a:pPr lvl="3"/>
             <a:r>
-              <a:rPr lang="en-US"/>
+              <a:rPr lang="en-US" smtClean="0"/>
               <a:t>Fourth level</a:t>
             </a:r>
           </a:p>
           <a:p>
             <a:pPr lvl="4"/>
             <a:r>
-              <a:rPr lang="en-US"/>
+              <a:rPr lang="en-US" smtClean="0"/>
               <a:t>Fifth level</a:t>
             </a:r>
+            <a:endParaRPr lang="en-US"/>
           </a:p>
         </p:txBody>
       </p:sp>
@@ -1719,7 +1911,7 @@
           <a:p>
             <a:fld id="{5BCAD085-E8A6-8845-BD4E-CB4CCA059FC4}" type="datetimeFigureOut">
               <a:rPr lang="en-US" smtClean="0"/>
-              <a:t>10/20/26</a:t>
+              <a:t>1/27/13</a:t>
             </a:fld>
             <a:endParaRPr lang="en-US"/>
           </a:p>
@@ -1817,9 +2009,10 @@
           </a:lstStyle>
           <a:p>
             <a:r>
-              <a:rPr lang="en-US"/>
+              <a:rPr lang="en-US" smtClean="0"/>
               <a:t>Click to edit Master title style</a:t>
             </a:r>
+            <a:endParaRPr lang="en-US"/>
           </a:p>
         </p:txBody>
       </p:sp>
@@ -1882,7 +2075,7 @@
           <a:p>
             <a:pPr lvl="0"/>
             <a:r>
-              <a:rPr lang="en-US"/>
+              <a:rPr lang="en-US" smtClean="0"/>
               <a:t>Click to edit Master text styles</a:t>
             </a:r>
           </a:p>
@@ -1938,37 +2131,38 @@
           <a:p>
             <a:pPr lvl="0"/>
             <a:r>
-              <a:rPr lang="en-US"/>
+              <a:rPr lang="en-US" smtClean="0"/>
               <a:t>Click to edit Master text styles</a:t>
             </a:r>
           </a:p>
           <a:p>
             <a:pPr lvl="1"/>
             <a:r>
-              <a:rPr lang="en-US"/>
+              <a:rPr lang="en-US" smtClean="0"/>
               <a:t>Second level</a:t>
             </a:r>
           </a:p>
           <a:p>
             <a:pPr lvl="2"/>
             <a:r>
-              <a:rPr lang="en-US"/>
+              <a:rPr lang="en-US" smtClean="0"/>
               <a:t>Third level</a:t>
             </a:r>
           </a:p>
           <a:p>
             <a:pPr lvl="3"/>
             <a:r>
-              <a:rPr lang="en-US"/>
+              <a:rPr lang="en-US" smtClean="0"/>
               <a:t>Fourth level</a:t>
             </a:r>
           </a:p>
           <a:p>
             <a:pPr lvl="4"/>
             <a:r>
-              <a:rPr lang="en-US"/>
+              <a:rPr lang="en-US" smtClean="0"/>
               <a:t>Fifth level</a:t>
             </a:r>
+            <a:endParaRPr lang="en-US"/>
           </a:p>
         </p:txBody>
       </p:sp>
@@ -2031,7 +2225,7 @@
           <a:p>
             <a:pPr lvl="0"/>
             <a:r>
-              <a:rPr lang="en-US"/>
+              <a:rPr lang="en-US" smtClean="0"/>
               <a:t>Click to edit Master text styles</a:t>
             </a:r>
           </a:p>
@@ -2087,37 +2281,38 @@
           <a:p>
             <a:pPr lvl="0"/>
             <a:r>
-              <a:rPr lang="en-US"/>
+              <a:rPr lang="en-US" smtClean="0"/>
               <a:t>Click to edit Master text styles</a:t>
             </a:r>
           </a:p>
           <a:p>
             <a:pPr lvl="1"/>
             <a:r>
-              <a:rPr lang="en-US"/>
+              <a:rPr lang="en-US" smtClean="0"/>
               <a:t>Second level</a:t>
             </a:r>
           </a:p>
           <a:p>
             <a:pPr lvl="2"/>
             <a:r>
-              <a:rPr lang="en-US"/>
+              <a:rPr lang="en-US" smtClean="0"/>
               <a:t>Third level</a:t>
             </a:r>
           </a:p>
           <a:p>
             <a:pPr lvl="3"/>
             <a:r>
-              <a:rPr lang="en-US"/>
+              <a:rPr lang="en-US" smtClean="0"/>
               <a:t>Fourth level</a:t>
             </a:r>
           </a:p>
           <a:p>
             <a:pPr lvl="4"/>
             <a:r>
-              <a:rPr lang="en-US"/>
+              <a:rPr lang="en-US" smtClean="0"/>
               <a:t>Fifth level</a:t>
             </a:r>
+            <a:endParaRPr lang="en-US"/>
           </a:p>
         </p:txBody>
       </p:sp>
@@ -2138,7 +2333,7 @@
           <a:p>
             <a:fld id="{5BCAD085-E8A6-8845-BD4E-CB4CCA059FC4}" type="datetimeFigureOut">
               <a:rPr lang="en-US" smtClean="0"/>
-              <a:t>10/20/26</a:t>
+              <a:t>1/27/13</a:t>
             </a:fld>
             <a:endParaRPr lang="en-US"/>
           </a:p>
@@ -2232,9 +2427,10 @@
           <a:lstStyle/>
           <a:p>
             <a:r>
-              <a:rPr lang="en-US"/>
+              <a:rPr lang="en-US" smtClean="0"/>
               <a:t>Click to edit Master title style</a:t>
             </a:r>
+            <a:endParaRPr lang="en-US"/>
           </a:p>
         </p:txBody>
       </p:sp>
@@ -2255,7 +2451,7 @@
           <a:p>
             <a:fld id="{5BCAD085-E8A6-8845-BD4E-CB4CCA059FC4}" type="datetimeFigureOut">
               <a:rPr lang="en-US" smtClean="0"/>
-              <a:t>10/20/26</a:t>
+              <a:t>1/27/13</a:t>
             </a:fld>
             <a:endParaRPr lang="en-US"/>
           </a:p>
@@ -2350,7 +2546,7 @@
           <a:p>
             <a:fld id="{5BCAD085-E8A6-8845-BD4E-CB4CCA059FC4}" type="datetimeFigureOut">
               <a:rPr lang="en-US" smtClean="0"/>
-              <a:t>10/20/26</a:t>
+              <a:t>1/27/13</a:t>
             </a:fld>
             <a:endParaRPr lang="en-US"/>
           </a:p>
@@ -2453,9 +2649,10 @@
           </a:lstStyle>
           <a:p>
             <a:r>
-              <a:rPr lang="en-US"/>
+              <a:rPr lang="en-US" smtClean="0"/>
               <a:t>Click to edit Master title style</a:t>
             </a:r>
+            <a:endParaRPr lang="en-US"/>
           </a:p>
         </p:txBody>
       </p:sp>
@@ -2509,37 +2706,38 @@
           <a:p>
             <a:pPr lvl="0"/>
             <a:r>
-              <a:rPr lang="en-US"/>
+              <a:rPr lang="en-US" smtClean="0"/>
               <a:t>Click to edit Master text styles</a:t>
             </a:r>
           </a:p>
           <a:p>
             <a:pPr lvl="1"/>
             <a:r>
-              <a:rPr lang="en-US"/>
+              <a:rPr lang="en-US" smtClean="0"/>
               <a:t>Second level</a:t>
             </a:r>
           </a:p>
           <a:p>
             <a:pPr lvl="2"/>
             <a:r>
-              <a:rPr lang="en-US"/>
+              <a:rPr lang="en-US" smtClean="0"/>
               <a:t>Third level</a:t>
             </a:r>
           </a:p>
           <a:p>
             <a:pPr lvl="3"/>
             <a:r>
-              <a:rPr lang="en-US"/>
+              <a:rPr lang="en-US" smtClean="0"/>
               <a:t>Fourth level</a:t>
             </a:r>
           </a:p>
           <a:p>
             <a:pPr lvl="4"/>
             <a:r>
-              <a:rPr lang="en-US"/>
+              <a:rPr lang="en-US" smtClean="0"/>
               <a:t>Fifth level</a:t>
             </a:r>
+            <a:endParaRPr lang="en-US"/>
           </a:p>
         </p:txBody>
       </p:sp>
@@ -2602,7 +2800,7 @@
           <a:p>
             <a:pPr lvl="0"/>
             <a:r>
-              <a:rPr lang="en-US"/>
+              <a:rPr lang="en-US" smtClean="0"/>
               <a:t>Click to edit Master text styles</a:t>
             </a:r>
           </a:p>
@@ -2625,7 +2823,7 @@
           <a:p>
             <a:fld id="{5BCAD085-E8A6-8845-BD4E-CB4CCA059FC4}" type="datetimeFigureOut">
               <a:rPr lang="en-US" smtClean="0"/>
-              <a:t>10/20/26</a:t>
+              <a:t>1/27/13</a:t>
             </a:fld>
             <a:endParaRPr lang="en-US"/>
           </a:p>
@@ -2728,9 +2926,10 @@
           </a:lstStyle>
           <a:p>
             <a:r>
-              <a:rPr lang="en-US"/>
+              <a:rPr lang="en-US" smtClean="0"/>
               <a:t>Click to edit Master title style</a:t>
             </a:r>
+            <a:endParaRPr lang="en-US"/>
           </a:p>
         </p:txBody>
       </p:sp>
@@ -2854,7 +3053,7 @@
           <a:p>
             <a:pPr lvl="0"/>
             <a:r>
-              <a:rPr lang="en-US"/>
+              <a:rPr lang="en-US" smtClean="0"/>
               <a:t>Click to edit Master text styles</a:t>
             </a:r>
           </a:p>
@@ -2877,7 +3076,7 @@
           <a:p>
             <a:fld id="{5BCAD085-E8A6-8845-BD4E-CB4CCA059FC4}" type="datetimeFigureOut">
               <a:rPr lang="en-US" smtClean="0"/>
-              <a:t>10/20/26</a:t>
+              <a:t>1/27/13</a:t>
             </a:fld>
             <a:endParaRPr lang="en-US"/>
           </a:p>
@@ -2986,9 +3185,10 @@
           <a:lstStyle/>
           <a:p>
             <a:r>
-              <a:rPr lang="en-US"/>
+              <a:rPr lang="en-US" smtClean="0"/>
               <a:t>Click to edit Master title style</a:t>
             </a:r>
+            <a:endParaRPr lang="en-US"/>
           </a:p>
         </p:txBody>
       </p:sp>
@@ -3019,37 +3219,38 @@
           <a:p>
             <a:pPr lvl="0"/>
             <a:r>
-              <a:rPr lang="en-US"/>
+              <a:rPr lang="en-US" smtClean="0"/>
               <a:t>Click to edit Master text styles</a:t>
             </a:r>
           </a:p>
           <a:p>
             <a:pPr lvl="1"/>
             <a:r>
-              <a:rPr lang="en-US"/>
+              <a:rPr lang="en-US" smtClean="0"/>
               <a:t>Second level</a:t>
             </a:r>
           </a:p>
           <a:p>
             <a:pPr lvl="2"/>
             <a:r>
-              <a:rPr lang="en-US"/>
+              <a:rPr lang="en-US" smtClean="0"/>
               <a:t>Third level</a:t>
             </a:r>
           </a:p>
           <a:p>
             <a:pPr lvl="3"/>
             <a:r>
-              <a:rPr lang="en-US"/>
+              <a:rPr lang="en-US" smtClean="0"/>
               <a:t>Fourth level</a:t>
             </a:r>
           </a:p>
           <a:p>
             <a:pPr lvl="4"/>
             <a:r>
-              <a:rPr lang="en-US"/>
+              <a:rPr lang="en-US" smtClean="0"/>
               <a:t>Fifth level</a:t>
             </a:r>
+            <a:endParaRPr lang="en-US"/>
           </a:p>
         </p:txBody>
       </p:sp>
@@ -3088,7 +3289,7 @@
           <a:p>
             <a:fld id="{5BCAD085-E8A6-8845-BD4E-CB4CCA059FC4}" type="datetimeFigureOut">
               <a:rPr lang="en-US" smtClean="0"/>
-              <a:t>10/20/26</a:t>
+              <a:t>1/27/13</a:t>
             </a:fld>
             <a:endParaRPr lang="en-US"/>
           </a:p>
@@ -3447,7 +3648,7 @@
 </file>
 
 <file path=ppt/slides/slide1.xml><?xml version="1.0" encoding="utf-8"?>
-<p:sld xmlns:a="http://schemas.openxmlformats.org/drawingml/2006/main" xmlns:r="http://schemas.openxmlformats.org/officeDocument/2006/relationships" xmlns:p="http://schemas.openxmlformats.org/presentationml/2006/main">
+<p:sld xmlns:a="http://schemas.openxmlformats.org/drawingml/2006/main" xmlns:p="http://schemas.openxmlformats.org/presentationml/2006/main" xmlns:r="http://schemas.openxmlformats.org/officeDocument/2006/relationships">
   <p:cSld>
     <p:spTree>
       <p:nvGrpSpPr>
@@ -3455,14 +3656,7 @@
         <p:cNvGrpSpPr/>
         <p:nvPr/>
       </p:nvGrpSpPr>
-      <p:grpSpPr>
-        <a:xfrm>
-          <a:off x="0" y="0"/>
-          <a:ext cx="0" cy="0"/>
-          <a:chOff x="0" y="0"/>
-          <a:chExt cx="0" cy="0"/>
-        </a:xfrm>
-      </p:grpSpPr>
+      <p:grpSpPr/>
       <p:sp>
         <p:nvSpPr>
           <p:cNvPr id="2" name="Rectangle 1"/>
@@ -3502,9 +3696,7 @@
         <p:txBody>
           <a:bodyPr rtlCol="0" anchor="ctr"/>
           <a:lstStyle/>
-          <a:p>
-            <a:endParaRPr/>
-          </a:p>
+          <a:p/>
         </p:txBody>
       </p:sp>
       <p:sp>
@@ -3524,7 +3716,7 @@
           <a:noFill/>
         </p:spPr>
         <p:txBody>
-          <a:bodyPr wrap="square" lIns="0" tIns="0" rIns="0" bIns="0" anchor="t">
+          <a:bodyPr wrap="square" anchor="t" lIns="0" rIns="0" tIns="0" bIns="0">
             <a:spAutoFit/>
           </a:bodyPr>
           <a:lstStyle/>
@@ -3541,7 +3733,7 @@
                 </a:solidFill>
                 <a:latin typeface="Helvetica Neue"/>
               </a:rPr>
-              <a:t>CSCI 544 GROUP 23 · SAROL ET AL., BIOINFORMATICS 40(7) 2024 · REPRODUCTION AND EXTENSION</a:t>
+              <a:t>CITEAUDIT · SAROL ET AL., BIOINFORMATICS 40(7) 2024 · REPRODUCTION AND EXTENSION</a:t>
             </a:r>
           </a:p>
         </p:txBody>
@@ -3563,7 +3755,7 @@
           <a:noFill/>
         </p:spPr>
         <p:txBody>
-          <a:bodyPr wrap="square" lIns="0" tIns="0" rIns="0" bIns="0" anchor="t">
+          <a:bodyPr wrap="square" anchor="t" lIns="0" rIns="0" tIns="0" bIns="0">
             <a:spAutoFit/>
           </a:bodyPr>
           <a:lstStyle/>
@@ -3624,9 +3816,7 @@
         <p:txBody>
           <a:bodyPr rtlCol="0" anchor="ctr"/>
           <a:lstStyle/>
-          <a:p>
-            <a:endParaRPr/>
-          </a:p>
+          <a:p/>
         </p:txBody>
       </p:sp>
       <p:sp>
@@ -3668,9 +3858,7 @@
         <p:txBody>
           <a:bodyPr rtlCol="0" anchor="ctr"/>
           <a:lstStyle/>
-          <a:p>
-            <a:endParaRPr/>
-          </a:p>
+          <a:p/>
         </p:txBody>
       </p:sp>
       <p:sp>
@@ -3690,7 +3878,7 @@
           <a:noFill/>
         </p:spPr>
         <p:txBody>
-          <a:bodyPr wrap="square" lIns="0" tIns="0" rIns="0" bIns="0" anchor="t">
+          <a:bodyPr wrap="square" anchor="t" lIns="0" rIns="0" tIns="0" bIns="0">
             <a:spAutoFit/>
           </a:bodyPr>
           <a:lstStyle/>
@@ -3820,7 +4008,7 @@
           <a:noFill/>
         </p:spPr>
         <p:txBody>
-          <a:bodyPr wrap="square" lIns="0" tIns="0" rIns="0" bIns="0" anchor="t">
+          <a:bodyPr wrap="square" anchor="t" lIns="0" rIns="0" tIns="0" bIns="0">
             <a:spAutoFit/>
           </a:bodyPr>
           <a:lstStyle/>
@@ -3859,7 +4047,7 @@
           <a:noFill/>
         </p:spPr>
         <p:txBody>
-          <a:bodyPr wrap="square" lIns="0" tIns="0" rIns="0" bIns="0" anchor="ctr">
+          <a:bodyPr wrap="square" anchor="ctr" lIns="0" rIns="0" tIns="0" bIns="0">
             <a:spAutoFit/>
           </a:bodyPr>
           <a:lstStyle/>
@@ -3898,7 +4086,7 @@
           <a:noFill/>
         </p:spPr>
         <p:txBody>
-          <a:bodyPr wrap="square" lIns="0" tIns="0" rIns="0" bIns="0" anchor="ctr">
+          <a:bodyPr wrap="square" anchor="ctr" lIns="0" rIns="0" tIns="0" bIns="0">
             <a:spAutoFit/>
           </a:bodyPr>
           <a:lstStyle/>
@@ -3937,7 +4125,7 @@
           <a:noFill/>
         </p:spPr>
         <p:txBody>
-          <a:bodyPr wrap="square" lIns="0" tIns="0" rIns="0" bIns="0" anchor="ctr">
+          <a:bodyPr wrap="square" anchor="ctr" lIns="0" rIns="0" tIns="0" bIns="0">
             <a:spAutoFit/>
           </a:bodyPr>
           <a:lstStyle/>
@@ -3976,7 +4164,7 @@
           <a:noFill/>
         </p:spPr>
         <p:txBody>
-          <a:bodyPr wrap="square" lIns="0" tIns="0" rIns="0" bIns="0" anchor="ctr">
+          <a:bodyPr wrap="square" anchor="ctr" lIns="0" rIns="0" tIns="0" bIns="0">
             <a:spAutoFit/>
           </a:bodyPr>
           <a:lstStyle/>
@@ -4015,7 +4203,7 @@
           <a:noFill/>
         </p:spPr>
         <p:txBody>
-          <a:bodyPr wrap="square" lIns="0" tIns="0" rIns="0" bIns="0" anchor="ctr">
+          <a:bodyPr wrap="square" anchor="ctr" lIns="0" rIns="0" tIns="0" bIns="0">
             <a:spAutoFit/>
           </a:bodyPr>
           <a:lstStyle/>
@@ -4054,7 +4242,7 @@
           <a:noFill/>
         </p:spPr>
         <p:txBody>
-          <a:bodyPr wrap="square" lIns="0" tIns="0" rIns="0" bIns="0" anchor="ctr">
+          <a:bodyPr wrap="square" anchor="ctr" lIns="0" rIns="0" tIns="0" bIns="0">
             <a:spAutoFit/>
           </a:bodyPr>
           <a:lstStyle/>
@@ -4115,9 +4303,7 @@
         <p:txBody>
           <a:bodyPr rtlCol="0" anchor="ctr"/>
           <a:lstStyle/>
-          <a:p>
-            <a:endParaRPr/>
-          </a:p>
+          <a:p/>
         </p:txBody>
       </p:sp>
       <p:sp>
@@ -4161,9 +4347,7 @@
         <p:txBody>
           <a:bodyPr rtlCol="0" anchor="ctr"/>
           <a:lstStyle/>
-          <a:p>
-            <a:endParaRPr/>
-          </a:p>
+          <a:p/>
         </p:txBody>
       </p:sp>
       <p:sp>
@@ -4183,7 +4367,7 @@
           <a:noFill/>
         </p:spPr>
         <p:txBody>
-          <a:bodyPr wrap="square" lIns="0" tIns="0" rIns="0" bIns="0" anchor="t">
+          <a:bodyPr wrap="square" anchor="t" lIns="0" rIns="0" tIns="0" bIns="0">
             <a:spAutoFit/>
           </a:bodyPr>
           <a:lstStyle/>
@@ -4260,7 +4444,7 @@
           <a:noFill/>
         </p:spPr>
         <p:txBody>
-          <a:bodyPr wrap="square" lIns="0" tIns="0" rIns="0" bIns="0" anchor="ctr">
+          <a:bodyPr wrap="square" anchor="ctr" lIns="0" rIns="0" tIns="0" bIns="0">
             <a:spAutoFit/>
           </a:bodyPr>
           <a:lstStyle/>
@@ -4323,9 +4507,7 @@
         <p:txBody>
           <a:bodyPr rtlCol="0" anchor="ctr"/>
           <a:lstStyle/>
-          <a:p>
-            <a:endParaRPr/>
-          </a:p>
+          <a:p/>
         </p:txBody>
       </p:sp>
       <p:sp>
@@ -4345,7 +4527,7 @@
           <a:noFill/>
         </p:spPr>
         <p:txBody>
-          <a:bodyPr wrap="square" lIns="0" tIns="0" rIns="0" bIns="0" anchor="t">
+          <a:bodyPr wrap="square" anchor="t" lIns="0" rIns="0" tIns="0" bIns="0">
             <a:spAutoFit/>
           </a:bodyPr>
           <a:lstStyle/>
@@ -4422,7 +4604,7 @@
           <a:noFill/>
         </p:spPr>
         <p:txBody>
-          <a:bodyPr wrap="square" lIns="0" tIns="0" rIns="0" bIns="0" anchor="ctr">
+          <a:bodyPr wrap="square" anchor="ctr" lIns="0" rIns="0" tIns="0" bIns="0">
             <a:spAutoFit/>
           </a:bodyPr>
           <a:lstStyle/>
@@ -4485,9 +4667,7 @@
         <p:txBody>
           <a:bodyPr rtlCol="0" anchor="ctr"/>
           <a:lstStyle/>
-          <a:p>
-            <a:endParaRPr/>
-          </a:p>
+          <a:p/>
         </p:txBody>
       </p:sp>
       <p:sp>
@@ -4507,7 +4687,7 @@
           <a:noFill/>
         </p:spPr>
         <p:txBody>
-          <a:bodyPr wrap="square" lIns="0" tIns="0" rIns="0" bIns="0" anchor="t">
+          <a:bodyPr wrap="square" anchor="t" lIns="0" rIns="0" tIns="0" bIns="0">
             <a:spAutoFit/>
           </a:bodyPr>
           <a:lstStyle/>
@@ -4584,7 +4764,7 @@
           <a:noFill/>
         </p:spPr>
         <p:txBody>
-          <a:bodyPr wrap="square" lIns="0" tIns="0" rIns="0" bIns="0" anchor="ctr">
+          <a:bodyPr wrap="square" anchor="ctr" lIns="0" rIns="0" tIns="0" bIns="0">
             <a:spAutoFit/>
           </a:bodyPr>
           <a:lstStyle/>
@@ -4623,7 +4803,7 @@
           <a:noFill/>
         </p:spPr>
         <p:txBody>
-          <a:bodyPr wrap="square" lIns="0" tIns="0" rIns="0" bIns="0" anchor="t">
+          <a:bodyPr wrap="square" anchor="t" lIns="0" rIns="0" tIns="0" bIns="0">
             <a:spAutoFit/>
           </a:bodyPr>
           <a:lstStyle/>
@@ -4671,7 +4851,7 @@
           <a:noFill/>
         </p:spPr>
         <p:txBody>
-          <a:bodyPr wrap="square" lIns="0" tIns="0" rIns="0" bIns="0" anchor="t">
+          <a:bodyPr wrap="square" anchor="t" lIns="0" rIns="0" tIns="0" bIns="0">
             <a:spAutoFit/>
           </a:bodyPr>
           <a:lstStyle/>
@@ -4719,7 +4899,7 @@
           <a:noFill/>
         </p:spPr>
         <p:txBody>
-          <a:bodyPr wrap="square" lIns="0" tIns="0" rIns="0" bIns="0" anchor="t">
+          <a:bodyPr wrap="square" anchor="t" lIns="0" rIns="0" tIns="0" bIns="0">
             <a:spAutoFit/>
           </a:bodyPr>
           <a:lstStyle/>
@@ -4767,7 +4947,7 @@
           <a:noFill/>
         </p:spPr>
         <p:txBody>
-          <a:bodyPr wrap="square" lIns="0" tIns="0" rIns="0" bIns="0" anchor="ctr">
+          <a:bodyPr wrap="square" anchor="ctr" lIns="0" rIns="0" tIns="0" bIns="0">
             <a:spAutoFit/>
           </a:bodyPr>
           <a:lstStyle/>
@@ -4806,7 +4986,7 @@
           <a:noFill/>
         </p:spPr>
         <p:txBody>
-          <a:bodyPr wrap="square" lIns="0" tIns="0" rIns="0" bIns="0" anchor="t">
+          <a:bodyPr wrap="square" anchor="t" lIns="0" rIns="0" tIns="0" bIns="0">
             <a:spAutoFit/>
           </a:bodyPr>
           <a:lstStyle/>
@@ -4854,7 +5034,7 @@
           <a:noFill/>
         </p:spPr>
         <p:txBody>
-          <a:bodyPr wrap="square" lIns="0" tIns="0" rIns="0" bIns="0" anchor="t">
+          <a:bodyPr wrap="square" anchor="t" lIns="0" rIns="0" tIns="0" bIns="0">
             <a:spAutoFit/>
           </a:bodyPr>
           <a:lstStyle/>
@@ -4902,7 +5082,7 @@
           <a:noFill/>
         </p:spPr>
         <p:txBody>
-          <a:bodyPr wrap="square" lIns="0" tIns="0" rIns="0" bIns="0" anchor="t">
+          <a:bodyPr wrap="square" anchor="t" lIns="0" rIns="0" tIns="0" bIns="0">
             <a:spAutoFit/>
           </a:bodyPr>
           <a:lstStyle/>
@@ -4950,7 +5130,7 @@
           <a:noFill/>
         </p:spPr>
         <p:txBody>
-          <a:bodyPr wrap="square" lIns="0" tIns="0" rIns="0" bIns="0" anchor="t">
+          <a:bodyPr wrap="square" anchor="t" lIns="0" rIns="0" tIns="0" bIns="0">
             <a:spAutoFit/>
           </a:bodyPr>
           <a:lstStyle/>
@@ -4981,7 +5161,7 @@
 </file>
 
 <file path=ppt/slides/slide2.xml><?xml version="1.0" encoding="utf-8"?>
-<p:sld xmlns:a="http://schemas.openxmlformats.org/drawingml/2006/main" xmlns:r="http://schemas.openxmlformats.org/officeDocument/2006/relationships" xmlns:p="http://schemas.openxmlformats.org/presentationml/2006/main">
+<p:sld xmlns:a="http://schemas.openxmlformats.org/drawingml/2006/main" xmlns:p="http://schemas.openxmlformats.org/presentationml/2006/main" xmlns:r="http://schemas.openxmlformats.org/officeDocument/2006/relationships">
   <p:cSld>
     <p:spTree>
       <p:nvGrpSpPr>
@@ -4989,14 +5169,7 @@
         <p:cNvGrpSpPr/>
         <p:nvPr/>
       </p:nvGrpSpPr>
-      <p:grpSpPr>
-        <a:xfrm>
-          <a:off x="0" y="0"/>
-          <a:ext cx="0" cy="0"/>
-          <a:chOff x="0" y="0"/>
-          <a:chExt cx="0" cy="0"/>
-        </a:xfrm>
-      </p:grpSpPr>
+      <p:grpSpPr/>
       <p:sp>
         <p:nvSpPr>
           <p:cNvPr id="2" name="Rectangle 1"/>
@@ -5005,7 +5178,7 @@
         </p:nvSpPr>
         <p:spPr>
           <a:xfrm>
-            <a:off x="0" y="13881"/>
+            <a:off x="0" y="0"/>
             <a:ext cx="12192000" cy="6858000"/>
           </a:xfrm>
           <a:prstGeom prst="rect">
@@ -5036,9 +5209,7 @@
         <p:txBody>
           <a:bodyPr rtlCol="0" anchor="ctr"/>
           <a:lstStyle/>
-          <a:p>
-            <a:endParaRPr/>
-          </a:p>
+          <a:p/>
         </p:txBody>
       </p:sp>
       <p:sp>
@@ -5058,7 +5229,7 @@
           <a:noFill/>
         </p:spPr>
         <p:txBody>
-          <a:bodyPr wrap="square" lIns="0" tIns="0" rIns="0" bIns="0" anchor="t">
+          <a:bodyPr wrap="square" anchor="t" lIns="0" rIns="0" tIns="0" bIns="0">
             <a:spAutoFit/>
           </a:bodyPr>
           <a:lstStyle/>
@@ -5097,7 +5268,7 @@
           <a:noFill/>
         </p:spPr>
         <p:txBody>
-          <a:bodyPr wrap="square" lIns="0" tIns="0" rIns="0" bIns="0" anchor="t">
+          <a:bodyPr wrap="square" anchor="t" lIns="0" rIns="0" tIns="0" bIns="0">
             <a:spAutoFit/>
           </a:bodyPr>
           <a:lstStyle/>
@@ -5136,7 +5307,7 @@
           <a:noFill/>
         </p:spPr>
         <p:txBody>
-          <a:bodyPr wrap="square" lIns="0" tIns="0" rIns="0" bIns="0" anchor="t">
+          <a:bodyPr wrap="square" anchor="t" lIns="0" rIns="0" tIns="0" bIns="0">
             <a:spAutoFit/>
           </a:bodyPr>
           <a:lstStyle/>
@@ -5164,17 +5335,11 @@
           <p:cNvGraphicFramePr>
             <a:graphicFrameLocks noGrp="1"/>
           </p:cNvGraphicFramePr>
-          <p:nvPr>
-            <p:extLst>
-              <p:ext uri="{D42A27DB-BD31-4B8C-83A1-F6EECF244321}">
-                <p14:modId xmlns:p14="http://schemas.microsoft.com/office/powerpoint/2010/main" val="1014702049"/>
-              </p:ext>
-            </p:extLst>
-          </p:nvPr>
+          <p:nvPr/>
         </p:nvGraphicFramePr>
         <p:xfrm>
           <a:off x="812800" y="1803400"/>
-          <a:ext cx="5468189" cy="1422400"/>
+          <a:ext cx="5468189" cy="1397000"/>
         </p:xfrm>
         <a:graphic>
           <a:graphicData uri="http://schemas.openxmlformats.org/drawingml/2006/table">
@@ -5183,34 +5348,10 @@
                 <a:tableStyleId>{5C22544A-7EE6-4342-B048-85BDC9FD1C3A}</a:tableStyleId>
               </a:tblPr>
               <a:tblGrid>
-                <a:gridCol w="1859184">
-                  <a:extLst>
-                    <a:ext uri="{9D8B030D-6E8A-4147-A177-3AD203B41FA5}">
-                      <a16:colId xmlns:a16="http://schemas.microsoft.com/office/drawing/2014/main" val="20000"/>
-                    </a:ext>
-                  </a:extLst>
-                </a:gridCol>
-                <a:gridCol w="1038956">
-                  <a:extLst>
-                    <a:ext uri="{9D8B030D-6E8A-4147-A177-3AD203B41FA5}">
-                      <a16:colId xmlns:a16="http://schemas.microsoft.com/office/drawing/2014/main" val="20001"/>
-                    </a:ext>
-                  </a:extLst>
-                </a:gridCol>
-                <a:gridCol w="1137507">
-                  <a:extLst>
-                    <a:ext uri="{9D8B030D-6E8A-4147-A177-3AD203B41FA5}">
-                      <a16:colId xmlns:a16="http://schemas.microsoft.com/office/drawing/2014/main" val="20002"/>
-                    </a:ext>
-                  </a:extLst>
-                </a:gridCol>
-                <a:gridCol w="1432542">
-                  <a:extLst>
-                    <a:ext uri="{9D8B030D-6E8A-4147-A177-3AD203B41FA5}">
-                      <a16:colId xmlns:a16="http://schemas.microsoft.com/office/drawing/2014/main" val="20003"/>
-                    </a:ext>
-                  </a:extLst>
-                </a:gridCol>
+                <a:gridCol w="1859184"/>
+                <a:gridCol w="1038956"/>
+                <a:gridCol w="1038956"/>
+                <a:gridCol w="1531093"/>
               </a:tblGrid>
               <a:tr h="279400">
                 <a:tc>
@@ -5230,7 +5371,7 @@
                       </a:r>
                     </a:p>
                   </a:txBody>
-                  <a:tcPr marL="88900" marR="88900" marT="50800" marB="50800" anchor="ctr">
+                  <a:tcPr anchor="ctr" marL="88900" marR="88900" marT="50800" marB="50800">
                     <a:solidFill>
                       <a:srgbClr val="ECEEE8"/>
                     </a:solidFill>
@@ -5253,7 +5394,7 @@
                       </a:r>
                     </a:p>
                   </a:txBody>
-                  <a:tcPr marL="88900" marR="88900" marT="50800" marB="50800" anchor="ctr">
+                  <a:tcPr anchor="ctr" marL="88900" marR="88900" marT="50800" marB="50800">
                     <a:solidFill>
                       <a:srgbClr val="ECEEE8"/>
                     </a:solidFill>
@@ -5276,7 +5417,7 @@
                       </a:r>
                     </a:p>
                   </a:txBody>
-                  <a:tcPr marL="88900" marR="88900" marT="50800" marB="50800" anchor="ctr">
+                  <a:tcPr anchor="ctr" marL="88900" marR="88900" marT="50800" marB="50800">
                     <a:solidFill>
                       <a:srgbClr val="ECEEE8"/>
                     </a:solidFill>
@@ -5299,17 +5440,12 @@
                       </a:r>
                     </a:p>
                   </a:txBody>
-                  <a:tcPr marL="88900" marR="88900" marT="50800" marB="50800" anchor="ctr">
+                  <a:tcPr anchor="ctr" marL="88900" marR="88900" marT="50800" marB="50800">
                     <a:solidFill>
                       <a:srgbClr val="ECEEE8"/>
                     </a:solidFill>
                   </a:tcPr>
                 </a:tc>
-                <a:extLst>
-                  <a:ext uri="{0D108BD9-81ED-4DB2-BD59-A6C34878D82A}">
-                    <a16:rowId xmlns:a16="http://schemas.microsoft.com/office/drawing/2014/main" val="10000"/>
-                  </a:ext>
-                </a:extLst>
               </a:tr>
               <a:tr h="279400">
                 <a:tc>
@@ -5329,7 +5465,7 @@
                       </a:r>
                     </a:p>
                   </a:txBody>
-                  <a:tcPr marL="88900" marR="88900" marT="50800" marB="50800" anchor="ctr">
+                  <a:tcPr anchor="ctr" marL="88900" marR="88900" marT="50800" marB="50800">
                     <a:solidFill>
                       <a:srgbClr val="FBFBF8"/>
                     </a:solidFill>
@@ -5352,7 +5488,7 @@
                       </a:r>
                     </a:p>
                   </a:txBody>
-                  <a:tcPr marL="88900" marR="88900" marT="50800" marB="50800" anchor="ctr">
+                  <a:tcPr anchor="ctr" marL="88900" marR="88900" marT="50800" marB="50800">
                     <a:solidFill>
                       <a:srgbClr val="FBFBF8"/>
                     </a:solidFill>
@@ -5375,7 +5511,7 @@
                       </a:r>
                     </a:p>
                   </a:txBody>
-                  <a:tcPr marL="88900" marR="88900" marT="50800" marB="50800" anchor="ctr">
+                  <a:tcPr anchor="ctr" marL="88900" marR="88900" marT="50800" marB="50800">
                     <a:solidFill>
                       <a:srgbClr val="FBFBF8"/>
                     </a:solidFill>
@@ -5398,17 +5534,12 @@
                       </a:r>
                     </a:p>
                   </a:txBody>
-                  <a:tcPr marL="88900" marR="88900" marT="50800" marB="50800" anchor="ctr">
+                  <a:tcPr anchor="ctr" marL="88900" marR="88900" marT="50800" marB="50800">
                     <a:solidFill>
                       <a:srgbClr val="FBFBF8"/>
                     </a:solidFill>
                   </a:tcPr>
                 </a:tc>
-                <a:extLst>
-                  <a:ext uri="{0D108BD9-81ED-4DB2-BD59-A6C34878D82A}">
-                    <a16:rowId xmlns:a16="http://schemas.microsoft.com/office/drawing/2014/main" val="10001"/>
-                  </a:ext>
-                </a:extLst>
               </a:tr>
               <a:tr h="279400">
                 <a:tc>
@@ -5428,7 +5559,7 @@
                       </a:r>
                     </a:p>
                   </a:txBody>
-                  <a:tcPr marL="88900" marR="88900" marT="50800" marB="50800" anchor="ctr">
+                  <a:tcPr anchor="ctr" marL="88900" marR="88900" marT="50800" marB="50800">
                     <a:solidFill>
                       <a:srgbClr val="FBFBF8"/>
                     </a:solidFill>
@@ -5451,7 +5582,7 @@
                       </a:r>
                     </a:p>
                   </a:txBody>
-                  <a:tcPr marL="88900" marR="88900" marT="50800" marB="50800" anchor="ctr">
+                  <a:tcPr anchor="ctr" marL="88900" marR="88900" marT="50800" marB="50800">
                     <a:solidFill>
                       <a:srgbClr val="FBFBF8"/>
                     </a:solidFill>
@@ -5474,7 +5605,7 @@
                       </a:r>
                     </a:p>
                   </a:txBody>
-                  <a:tcPr marL="88900" marR="88900" marT="50800" marB="50800" anchor="ctr">
+                  <a:tcPr anchor="ctr" marL="88900" marR="88900" marT="50800" marB="50800">
                     <a:solidFill>
                       <a:srgbClr val="FBFBF8"/>
                     </a:solidFill>
@@ -5497,17 +5628,12 @@
                       </a:r>
                     </a:p>
                   </a:txBody>
-                  <a:tcPr marL="88900" marR="88900" marT="50800" marB="50800" anchor="ctr">
+                  <a:tcPr anchor="ctr" marL="88900" marR="88900" marT="50800" marB="50800">
                     <a:solidFill>
                       <a:srgbClr val="FBFBF8"/>
                     </a:solidFill>
                   </a:tcPr>
                 </a:tc>
-                <a:extLst>
-                  <a:ext uri="{0D108BD9-81ED-4DB2-BD59-A6C34878D82A}">
-                    <a16:rowId xmlns:a16="http://schemas.microsoft.com/office/drawing/2014/main" val="10002"/>
-                  </a:ext>
-                </a:extLst>
               </a:tr>
               <a:tr h="279400">
                 <a:tc>
@@ -5527,7 +5653,7 @@
                       </a:r>
                     </a:p>
                   </a:txBody>
-                  <a:tcPr marL="88900" marR="88900" marT="50800" marB="50800" anchor="ctr">
+                  <a:tcPr anchor="ctr" marL="88900" marR="88900" marT="50800" marB="50800">
                     <a:solidFill>
                       <a:srgbClr val="FBFBF8"/>
                     </a:solidFill>
@@ -5550,7 +5676,7 @@
                       </a:r>
                     </a:p>
                   </a:txBody>
-                  <a:tcPr marL="88900" marR="88900" marT="50800" marB="50800" anchor="ctr">
+                  <a:tcPr anchor="ctr" marL="88900" marR="88900" marT="50800" marB="50800">
                     <a:solidFill>
                       <a:srgbClr val="FBFBF8"/>
                     </a:solidFill>
@@ -5573,7 +5699,7 @@
                       </a:r>
                     </a:p>
                   </a:txBody>
-                  <a:tcPr marL="88900" marR="88900" marT="50800" marB="50800" anchor="ctr">
+                  <a:tcPr anchor="ctr" marL="88900" marR="88900" marT="50800" marB="50800">
                     <a:solidFill>
                       <a:srgbClr val="FBFBF8"/>
                     </a:solidFill>
@@ -5596,17 +5722,12 @@
                       </a:r>
                     </a:p>
                   </a:txBody>
-                  <a:tcPr marL="88900" marR="88900" marT="50800" marB="50800" anchor="ctr">
+                  <a:tcPr anchor="ctr" marL="88900" marR="88900" marT="50800" marB="50800">
                     <a:solidFill>
                       <a:srgbClr val="FBFBF8"/>
                     </a:solidFill>
                   </a:tcPr>
                 </a:tc>
-                <a:extLst>
-                  <a:ext uri="{0D108BD9-81ED-4DB2-BD59-A6C34878D82A}">
-                    <a16:rowId xmlns:a16="http://schemas.microsoft.com/office/drawing/2014/main" val="10003"/>
-                  </a:ext>
-                </a:extLst>
               </a:tr>
               <a:tr h="279400">
                 <a:tc>
@@ -5626,7 +5747,7 @@
                       </a:r>
                     </a:p>
                   </a:txBody>
-                  <a:tcPr marL="88900" marR="88900" marT="50800" marB="50800" anchor="ctr">
+                  <a:tcPr anchor="ctr" marL="88900" marR="88900" marT="50800" marB="50800">
                     <a:solidFill>
                       <a:srgbClr val="FBFBF8"/>
                     </a:solidFill>
@@ -5649,7 +5770,7 @@
                       </a:r>
                     </a:p>
                   </a:txBody>
-                  <a:tcPr marL="88900" marR="88900" marT="50800" marB="50800" anchor="ctr">
+                  <a:tcPr anchor="ctr" marL="88900" marR="88900" marT="50800" marB="50800">
                     <a:solidFill>
                       <a:srgbClr val="FBFBF8"/>
                     </a:solidFill>
@@ -5672,7 +5793,7 @@
                       </a:r>
                     </a:p>
                   </a:txBody>
-                  <a:tcPr marL="88900" marR="88900" marT="50800" marB="50800" anchor="ctr">
+                  <a:tcPr anchor="ctr" marL="88900" marR="88900" marT="50800" marB="50800">
                     <a:solidFill>
                       <a:srgbClr val="FBFBF8"/>
                     </a:solidFill>
@@ -5685,7 +5806,7 @@
                     <a:p>
                       <a:pPr algn="r"/>
                       <a:r>
-                        <a:rPr sz="1200" b="0" dirty="0">
+                        <a:rPr sz="1200" b="0">
                           <a:solidFill>
                             <a:srgbClr val="B4530A"/>
                           </a:solidFill>
@@ -5695,17 +5816,12 @@
                       </a:r>
                     </a:p>
                   </a:txBody>
-                  <a:tcPr marL="88900" marR="88900" marT="50800" marB="50800" anchor="ctr">
+                  <a:tcPr anchor="ctr" marL="88900" marR="88900" marT="50800" marB="50800">
                     <a:solidFill>
                       <a:srgbClr val="FBFBF8"/>
                     </a:solidFill>
                   </a:tcPr>
                 </a:tc>
-                <a:extLst>
-                  <a:ext uri="{0D108BD9-81ED-4DB2-BD59-A6C34878D82A}">
-                    <a16:rowId xmlns:a16="http://schemas.microsoft.com/office/drawing/2014/main" val="10004"/>
-                  </a:ext>
-                </a:extLst>
               </a:tr>
             </a:tbl>
           </a:graphicData>
@@ -5750,9 +5866,7 @@
         <p:txBody>
           <a:bodyPr rtlCol="0" anchor="ctr"/>
           <a:lstStyle/>
-          <a:p>
-            <a:endParaRPr/>
-          </a:p>
+          <a:p/>
         </p:txBody>
       </p:sp>
       <p:sp>
@@ -5772,7 +5886,7 @@
           <a:noFill/>
         </p:spPr>
         <p:txBody>
-          <a:bodyPr wrap="square" lIns="0" tIns="0" rIns="0" bIns="0" anchor="t">
+          <a:bodyPr wrap="square" anchor="t" lIns="0" rIns="0" tIns="0" bIns="0">
             <a:spAutoFit/>
           </a:bodyPr>
           <a:lstStyle/>
@@ -5783,7 +5897,7 @@
               </a:lnSpc>
             </a:pPr>
             <a:r>
-              <a:rPr sz="1200" b="0" i="0" dirty="0">
+              <a:rPr sz="1200" b="0" i="0">
                 <a:solidFill>
                   <a:srgbClr val="6A7179"/>
                 </a:solidFill>
@@ -5833,9 +5947,7 @@
         <p:txBody>
           <a:bodyPr rtlCol="0" anchor="ctr"/>
           <a:lstStyle/>
-          <a:p>
-            <a:endParaRPr/>
-          </a:p>
+          <a:p/>
         </p:txBody>
       </p:sp>
       <p:sp>
@@ -5877,9 +5989,7 @@
         <p:txBody>
           <a:bodyPr rtlCol="0" anchor="ctr"/>
           <a:lstStyle/>
-          <a:p>
-            <a:endParaRPr/>
-          </a:p>
+          <a:p/>
         </p:txBody>
       </p:sp>
       <p:sp>
@@ -5899,7 +6009,7 @@
           <a:noFill/>
         </p:spPr>
         <p:txBody>
-          <a:bodyPr wrap="square" lIns="0" tIns="0" rIns="0" bIns="0" anchor="t">
+          <a:bodyPr wrap="square" anchor="t" lIns="0" rIns="0" tIns="0" bIns="0">
             <a:spAutoFit/>
           </a:bodyPr>
           <a:lstStyle/>
@@ -5910,7 +6020,7 @@
               </a:lnSpc>
             </a:pPr>
             <a:r>
-              <a:rPr sz="1200" b="1" i="0" spc="50" dirty="0">
+              <a:rPr sz="1200" b="1" i="0" spc="50">
                 <a:solidFill>
                   <a:srgbClr val="2D5F8B"/>
                 </a:solidFill>
@@ -5938,7 +6048,7 @@
           <a:noFill/>
         </p:spPr>
         <p:txBody>
-          <a:bodyPr wrap="square" lIns="0" tIns="0" rIns="0" bIns="0" anchor="t">
+          <a:bodyPr wrap="square" anchor="t" lIns="0" rIns="0" tIns="0" bIns="0">
             <a:spAutoFit/>
           </a:bodyPr>
           <a:lstStyle/>
@@ -5949,31 +6059,13 @@
               </a:lnSpc>
             </a:pPr>
             <a:r>
-              <a:rPr sz="1300" b="1" i="0" dirty="0">
+              <a:rPr sz="1300" b="1" i="0">
                 <a:solidFill>
                   <a:srgbClr val="14213D"/>
                 </a:solidFill>
                 <a:latin typeface="Helvetica Neue"/>
               </a:rPr>
-              <a:t>Drop BM25, </a:t>
-            </a:r>
-            <a:r>
-              <a:rPr sz="1300" b="1" i="0" dirty="0" err="1">
-                <a:solidFill>
-                  <a:srgbClr val="14213D"/>
-                </a:solidFill>
-                <a:latin typeface="Helvetica Neue"/>
-              </a:rPr>
-              <a:t>rerank</a:t>
-            </a:r>
-            <a:r>
-              <a:rPr sz="1300" b="1" i="0" dirty="0">
-                <a:solidFill>
-                  <a:srgbClr val="14213D"/>
-                </a:solidFill>
-                <a:latin typeface="Helvetica Neue"/>
-              </a:rPr>
-              <a:t> the whole pool</a:t>
+              <a:t>Drop BM25, rerank the whole pool</a:t>
             </a:r>
           </a:p>
         </p:txBody>
@@ -5995,7 +6087,7 @@
           <a:noFill/>
         </p:spPr>
         <p:txBody>
-          <a:bodyPr wrap="square" lIns="0" tIns="0" rIns="0" bIns="0" anchor="ctr">
+          <a:bodyPr wrap="square" anchor="ctr" lIns="0" rIns="0" tIns="0" bIns="0">
             <a:spAutoFit/>
           </a:bodyPr>
           <a:lstStyle/>
@@ -6006,7 +6098,7 @@
               </a:lnSpc>
             </a:pPr>
             <a:r>
-              <a:rPr sz="1200" b="0" i="0" dirty="0">
+              <a:rPr sz="1200" b="0" i="0">
                 <a:solidFill>
                   <a:srgbClr val="14213D"/>
                 </a:solidFill>
@@ -6034,7 +6126,7 @@
           <a:noFill/>
         </p:spPr>
         <p:txBody>
-          <a:bodyPr wrap="square" lIns="0" tIns="0" rIns="0" bIns="0" anchor="ctr">
+          <a:bodyPr wrap="square" anchor="ctr" lIns="0" rIns="0" tIns="0" bIns="0">
             <a:spAutoFit/>
           </a:bodyPr>
           <a:lstStyle/>
@@ -6073,7 +6165,7 @@
           <a:noFill/>
         </p:spPr>
         <p:txBody>
-          <a:bodyPr wrap="square" lIns="0" tIns="0" rIns="0" bIns="0" anchor="ctr">
+          <a:bodyPr wrap="square" anchor="ctr" lIns="0" rIns="0" tIns="0" bIns="0">
             <a:spAutoFit/>
           </a:bodyPr>
           <a:lstStyle/>
@@ -6084,7 +6176,7 @@
               </a:lnSpc>
             </a:pPr>
             <a:r>
-              <a:rPr sz="1200" b="0" i="0" dirty="0">
+              <a:rPr sz="1200" b="0" i="0">
                 <a:solidFill>
                   <a:srgbClr val="14213D"/>
                 </a:solidFill>
@@ -6112,7 +6204,7 @@
           <a:noFill/>
         </p:spPr>
         <p:txBody>
-          <a:bodyPr wrap="square" lIns="0" tIns="0" rIns="0" bIns="0" anchor="ctr">
+          <a:bodyPr wrap="square" anchor="ctr" lIns="0" rIns="0" tIns="0" bIns="0">
             <a:spAutoFit/>
           </a:bodyPr>
           <a:lstStyle/>
@@ -6151,7 +6243,7 @@
           <a:noFill/>
         </p:spPr>
         <p:txBody>
-          <a:bodyPr wrap="square" lIns="0" tIns="0" rIns="0" bIns="0" anchor="t">
+          <a:bodyPr wrap="square" anchor="t" lIns="0" rIns="0" tIns="0" bIns="0">
             <a:spAutoFit/>
           </a:bodyPr>
           <a:lstStyle/>
@@ -6162,49 +6254,22 @@
               </a:lnSpc>
             </a:pPr>
             <a:r>
-              <a:rPr sz="1200" b="1" i="0" dirty="0" err="1">
+              <a:rPr sz="1200" b="1" i="0">
                 <a:solidFill>
                   <a:srgbClr val="14213D"/>
                 </a:solidFill>
                 <a:latin typeface="Helvetica Neue"/>
               </a:rPr>
-              <a:t>Δ</a:t>
-            </a:r>
-            <a:r>
-              <a:rPr sz="1200" b="1" i="0" dirty="0">
-                <a:solidFill>
-                  <a:srgbClr val="14213D"/>
+              <a:t>Δ +0.012 ±0.014</a:t>
+            </a:r>
+            <a:r>
+              <a:rPr sz="1200" b="0" i="0">
+                <a:solidFill>
+                  <a:srgbClr val="4A5568"/>
                 </a:solidFill>
                 <a:latin typeface="Helvetica Neue"/>
               </a:rPr>
-              <a:t> +0.012 ±0.014</a:t>
-            </a:r>
-            <a:r>
-              <a:rPr sz="1200" b="0" i="0" dirty="0">
-                <a:solidFill>
-                  <a:srgbClr val="4A5568"/>
-                </a:solidFill>
-                <a:latin typeface="Helvetica Neue"/>
-              </a:rPr>
-              <a:t> — the interval includes zero and it wins on only 10 of 20 articles, at 4.0× the candidates. The depth-60 cut does discard 29% of the gold sentences, yet MonoT5 given all of them recovers none of it. The limit is the </a:t>
-            </a:r>
-            <a:r>
-              <a:rPr sz="1200" b="0" i="0" dirty="0" err="1">
-                <a:solidFill>
-                  <a:srgbClr val="4A5568"/>
-                </a:solidFill>
-                <a:latin typeface="Helvetica Neue"/>
-              </a:rPr>
-              <a:t>reranker</a:t>
-            </a:r>
-            <a:r>
-              <a:rPr sz="1200" b="0" i="0" dirty="0">
-                <a:solidFill>
-                  <a:srgbClr val="4A5568"/>
-                </a:solidFill>
-                <a:latin typeface="Helvetica Neue"/>
-              </a:rPr>
-              <a:t>, not the filter.</a:t>
+              <a:t> — the interval includes zero and it wins on only 10 of 20 articles, at 4.0× the candidates. The depth-60 cut does discard 29% of the gold sentences, yet MonoT5 given all of them recovers none of it. The limit is the reranker, not the filter.</a:t>
             </a:r>
           </a:p>
         </p:txBody>
@@ -6250,9 +6315,7 @@
         <p:txBody>
           <a:bodyPr rtlCol="0" anchor="ctr"/>
           <a:lstStyle/>
-          <a:p>
-            <a:endParaRPr/>
-          </a:p>
+          <a:p/>
         </p:txBody>
       </p:sp>
       <p:sp>
@@ -6272,7 +6335,7 @@
           <a:noFill/>
         </p:spPr>
         <p:txBody>
-          <a:bodyPr wrap="square" lIns="0" tIns="0" rIns="0" bIns="0" anchor="ctr">
+          <a:bodyPr wrap="square" anchor="ctr" lIns="0" rIns="0" tIns="0" bIns="0">
             <a:spAutoFit/>
           </a:bodyPr>
           <a:lstStyle/>
@@ -6283,7 +6346,7 @@
               </a:lnSpc>
             </a:pPr>
             <a:r>
-              <a:rPr sz="1200" b="1" i="0" dirty="0">
+              <a:rPr sz="1200" b="1" i="0">
                 <a:solidFill>
                   <a:srgbClr val="E8A96A"/>
                 </a:solidFill>
@@ -6292,7 +6355,7 @@
               <a:t>Downstream: </a:t>
             </a:r>
             <a:r>
-              <a:rPr sz="1200" b="0" i="0" dirty="0">
+              <a:rPr sz="1200" b="0" i="0">
                 <a:solidFill>
                   <a:srgbClr val="DCE4E8"/>
                 </a:solidFill>
@@ -6320,7 +6383,7 @@
           <a:noFill/>
         </p:spPr>
         <p:txBody>
-          <a:bodyPr wrap="square" lIns="0" tIns="0" rIns="0" bIns="0" anchor="t">
+          <a:bodyPr wrap="square" anchor="t" lIns="0" rIns="0" tIns="0" bIns="0">
             <a:spAutoFit/>
           </a:bodyPr>
           <a:lstStyle/>
@@ -6381,9 +6444,7 @@
         <p:txBody>
           <a:bodyPr rtlCol="0" anchor="ctr"/>
           <a:lstStyle/>
-          <a:p>
-            <a:endParaRPr/>
-          </a:p>
+          <a:p/>
         </p:txBody>
       </p:sp>
       <p:sp>
@@ -6425,9 +6486,7 @@
         <p:txBody>
           <a:bodyPr rtlCol="0" anchor="ctr"/>
           <a:lstStyle/>
-          <a:p>
-            <a:endParaRPr/>
-          </a:p>
+          <a:p/>
         </p:txBody>
       </p:sp>
       <p:sp>
@@ -6447,7 +6506,7 @@
           <a:noFill/>
         </p:spPr>
         <p:txBody>
-          <a:bodyPr wrap="square" lIns="0" tIns="0" rIns="0" bIns="0" anchor="t">
+          <a:bodyPr wrap="square" anchor="t" lIns="0" rIns="0" tIns="0" bIns="0">
             <a:spAutoFit/>
           </a:bodyPr>
           <a:lstStyle/>
@@ -6546,9 +6605,7 @@
         <p:txBody>
           <a:bodyPr rtlCol="0" anchor="ctr"/>
           <a:lstStyle/>
-          <a:p>
-            <a:endParaRPr/>
-          </a:p>
+          <a:p/>
         </p:txBody>
       </p:sp>
       <p:sp>
@@ -6590,9 +6647,7 @@
         <p:txBody>
           <a:bodyPr rtlCol="0" anchor="ctr"/>
           <a:lstStyle/>
-          <a:p>
-            <a:endParaRPr/>
-          </a:p>
+          <a:p/>
         </p:txBody>
       </p:sp>
       <p:sp>
@@ -6612,7 +6667,7 @@
           <a:noFill/>
         </p:spPr>
         <p:txBody>
-          <a:bodyPr wrap="square" lIns="0" tIns="0" rIns="0" bIns="0" anchor="t">
+          <a:bodyPr wrap="square" anchor="t" lIns="0" rIns="0" tIns="0" bIns="0">
             <a:spAutoFit/>
           </a:bodyPr>
           <a:lstStyle/>
@@ -6711,9 +6766,7 @@
         <p:txBody>
           <a:bodyPr rtlCol="0" anchor="ctr"/>
           <a:lstStyle/>
-          <a:p>
-            <a:endParaRPr/>
-          </a:p>
+          <a:p/>
         </p:txBody>
       </p:sp>
       <p:sp>
@@ -6755,9 +6808,7 @@
         <p:txBody>
           <a:bodyPr rtlCol="0" anchor="ctr"/>
           <a:lstStyle/>
-          <a:p>
-            <a:endParaRPr/>
-          </a:p>
+          <a:p/>
         </p:txBody>
       </p:sp>
       <p:sp>
@@ -6777,7 +6828,7 @@
           <a:noFill/>
         </p:spPr>
         <p:txBody>
-          <a:bodyPr wrap="square" lIns="0" tIns="0" rIns="0" bIns="0" anchor="t">
+          <a:bodyPr wrap="square" anchor="t" lIns="0" rIns="0" tIns="0" bIns="0">
             <a:spAutoFit/>
           </a:bodyPr>
           <a:lstStyle/>
@@ -6876,9 +6927,7 @@
         <p:txBody>
           <a:bodyPr rtlCol="0" anchor="ctr"/>
           <a:lstStyle/>
-          <a:p>
-            <a:endParaRPr/>
-          </a:p>
+          <a:p/>
         </p:txBody>
       </p:sp>
       <p:sp>
@@ -6920,9 +6969,7 @@
         <p:txBody>
           <a:bodyPr rtlCol="0" anchor="ctr"/>
           <a:lstStyle/>
-          <a:p>
-            <a:endParaRPr/>
-          </a:p>
+          <a:p/>
         </p:txBody>
       </p:sp>
       <p:sp>
@@ -6942,7 +6989,7 @@
           <a:noFill/>
         </p:spPr>
         <p:txBody>
-          <a:bodyPr wrap="square" lIns="0" tIns="0" rIns="0" bIns="0" anchor="t">
+          <a:bodyPr wrap="square" anchor="t" lIns="0" rIns="0" tIns="0" bIns="0">
             <a:spAutoFit/>
           </a:bodyPr>
           <a:lstStyle/>
@@ -7019,7 +7066,7 @@
           <a:noFill/>
         </p:spPr>
         <p:txBody>
-          <a:bodyPr wrap="square" lIns="0" tIns="0" rIns="0" bIns="0" anchor="t">
+          <a:bodyPr wrap="square" anchor="t" lIns="0" rIns="0" tIns="0" bIns="0">
             <a:spAutoFit/>
           </a:bodyPr>
           <a:lstStyle/>
@@ -7380,44 +7427,44 @@
         <a:sysClr val="window" lastClr="FFFFFF"/>
       </a:lt1>
       <a:dk2>
-        <a:srgbClr val="0E2841"/>
+        <a:srgbClr val="1F497D"/>
       </a:dk2>
       <a:lt2>
-        <a:srgbClr val="E8E8E8"/>
+        <a:srgbClr val="EEECE1"/>
       </a:lt2>
       <a:accent1>
-        <a:srgbClr val="156082"/>
+        <a:srgbClr val="4F81BD"/>
       </a:accent1>
       <a:accent2>
-        <a:srgbClr val="E97132"/>
+        <a:srgbClr val="C0504D"/>
       </a:accent2>
       <a:accent3>
-        <a:srgbClr val="196B24"/>
+        <a:srgbClr val="9BBB59"/>
       </a:accent3>
       <a:accent4>
-        <a:srgbClr val="0F9ED5"/>
+        <a:srgbClr val="8064A2"/>
       </a:accent4>
       <a:accent5>
-        <a:srgbClr val="A02B93"/>
+        <a:srgbClr val="4BACC6"/>
       </a:accent5>
       <a:accent6>
-        <a:srgbClr val="4EA72E"/>
+        <a:srgbClr val="F79646"/>
       </a:accent6>
       <a:hlink>
-        <a:srgbClr val="467886"/>
+        <a:srgbClr val="0000FF"/>
       </a:hlink>
       <a:folHlink>
-        <a:srgbClr val="96607D"/>
+        <a:srgbClr val="800080"/>
       </a:folHlink>
     </a:clrScheme>
     <a:fontScheme name="Office">
       <a:majorFont>
-        <a:latin typeface="Aptos Display" panose="02110004020202020204"/>
+        <a:latin typeface="Calibri"/>
         <a:ea typeface=""/>
         <a:cs typeface=""/>
-        <a:font script="Jpan" typeface="游ゴシック Light"/>
+        <a:font script="Jpan" typeface="ＭＳ Ｐゴシック"/>
         <a:font script="Hang" typeface="맑은 고딕"/>
-        <a:font script="Hans" typeface="等线 Light"/>
+        <a:font script="Hans" typeface="宋体"/>
         <a:font script="Hant" typeface="新細明體"/>
         <a:font script="Arab" typeface="Times New Roman"/>
         <a:font script="Hebr" typeface="Times New Roman"/>
@@ -7445,31 +7492,14 @@
         <a:font script="Viet" typeface="Times New Roman"/>
         <a:font script="Uigh" typeface="Microsoft Uighur"/>
         <a:font script="Geor" typeface="Sylfaen"/>
-        <a:font script="Armn" typeface="Arial"/>
-        <a:font script="Bugi" typeface="Leelawadee UI"/>
-        <a:font script="Bopo" typeface="Microsoft JhengHei"/>
-        <a:font script="Java" typeface="Javanese Text"/>
-        <a:font script="Lisu" typeface="Segoe UI"/>
-        <a:font script="Mymr" typeface="Myanmar Text"/>
-        <a:font script="Nkoo" typeface="Ebrima"/>
-        <a:font script="Olck" typeface="Nirmala UI"/>
-        <a:font script="Osma" typeface="Ebrima"/>
-        <a:font script="Phag" typeface="Phagspa"/>
-        <a:font script="Syrn" typeface="Estrangelo Edessa"/>
-        <a:font script="Syrj" typeface="Estrangelo Edessa"/>
-        <a:font script="Syre" typeface="Estrangelo Edessa"/>
-        <a:font script="Sora" typeface="Nirmala UI"/>
-        <a:font script="Tale" typeface="Microsoft Tai Le"/>
-        <a:font script="Talu" typeface="Microsoft New Tai Lue"/>
-        <a:font script="Tfng" typeface="Ebrima"/>
       </a:majorFont>
       <a:minorFont>
-        <a:latin typeface="Aptos" panose="02110004020202020204"/>
+        <a:latin typeface="Calibri"/>
         <a:ea typeface=""/>
         <a:cs typeface=""/>
-        <a:font script="Jpan" typeface="游ゴシック"/>
+        <a:font script="Jpan" typeface="ＭＳ Ｐゴシック"/>
         <a:font script="Hang" typeface="맑은 고딕"/>
-        <a:font script="Hans" typeface="等线"/>
+        <a:font script="Hans" typeface="宋体"/>
         <a:font script="Hant" typeface="新細明體"/>
         <a:font script="Arab" typeface="Arial"/>
         <a:font script="Hebr" typeface="Arial"/>
@@ -7497,23 +7527,6 @@
         <a:font script="Viet" typeface="Arial"/>
         <a:font script="Uigh" typeface="Microsoft Uighur"/>
         <a:font script="Geor" typeface="Sylfaen"/>
-        <a:font script="Armn" typeface="Arial"/>
-        <a:font script="Bugi" typeface="Leelawadee UI"/>
-        <a:font script="Bopo" typeface="Microsoft JhengHei"/>
-        <a:font script="Java" typeface="Javanese Text"/>
-        <a:font script="Lisu" typeface="Segoe UI"/>
-        <a:font script="Mymr" typeface="Myanmar Text"/>
-        <a:font script="Nkoo" typeface="Ebrima"/>
-        <a:font script="Olck" typeface="Nirmala UI"/>
-        <a:font script="Osma" typeface="Ebrima"/>
-        <a:font script="Phag" typeface="Phagspa"/>
-        <a:font script="Syrn" typeface="Estrangelo Edessa"/>
-        <a:font script="Syrj" typeface="Estrangelo Edessa"/>
-        <a:font script="Syre" typeface="Estrangelo Edessa"/>
-        <a:font script="Sora" typeface="Nirmala UI"/>
-        <a:font script="Tale" typeface="Microsoft Tai Le"/>
-        <a:font script="Talu" typeface="Microsoft New Tai Lue"/>
-        <a:font script="Tfng" typeface="Ebrima"/>
       </a:minorFont>
     </a:fontScheme>
     <a:fmtScheme name="Office">
@@ -7525,136 +7538,180 @@
           <a:gsLst>
             <a:gs pos="0">
               <a:schemeClr val="phClr">
-                <a:lumMod val="110000"/>
-                <a:satMod val="105000"/>
-                <a:tint val="67000"/>
+                <a:tint val="50000"/>
+                <a:satMod val="300000"/>
               </a:schemeClr>
             </a:gs>
-            <a:gs pos="50000">
+            <a:gs pos="35000">
               <a:schemeClr val="phClr">
-                <a:lumMod val="105000"/>
-                <a:satMod val="103000"/>
-                <a:tint val="73000"/>
+                <a:tint val="37000"/>
+                <a:satMod val="300000"/>
               </a:schemeClr>
             </a:gs>
             <a:gs pos="100000">
               <a:schemeClr val="phClr">
-                <a:lumMod val="105000"/>
-                <a:satMod val="109000"/>
-                <a:tint val="81000"/>
+                <a:tint val="15000"/>
+                <a:satMod val="350000"/>
               </a:schemeClr>
             </a:gs>
           </a:gsLst>
-          <a:lin ang="5400000" scaled="0"/>
+          <a:lin ang="16200000" scaled="1"/>
         </a:gradFill>
         <a:gradFill rotWithShape="1">
           <a:gsLst>
             <a:gs pos="0">
               <a:schemeClr val="phClr">
-                <a:satMod val="103000"/>
-                <a:lumMod val="102000"/>
-                <a:tint val="94000"/>
-              </a:schemeClr>
-            </a:gs>
-            <a:gs pos="50000">
-              <a:schemeClr val="phClr">
-                <a:satMod val="110000"/>
-                <a:lumMod val="100000"/>
+                <a:tint val="100000"/>
                 <a:shade val="100000"/>
+                <a:satMod val="130000"/>
               </a:schemeClr>
             </a:gs>
             <a:gs pos="100000">
               <a:schemeClr val="phClr">
-                <a:lumMod val="99000"/>
-                <a:satMod val="120000"/>
-                <a:shade val="78000"/>
+                <a:tint val="50000"/>
+                <a:shade val="100000"/>
+                <a:satMod val="350000"/>
               </a:schemeClr>
             </a:gs>
           </a:gsLst>
-          <a:lin ang="5400000" scaled="0"/>
+          <a:lin ang="16200000" scaled="0"/>
         </a:gradFill>
       </a:fillStyleLst>
       <a:lnStyleLst>
-        <a:ln w="12700" cap="flat" cmpd="sng" algn="ctr">
+        <a:ln w="9525" cap="flat" cmpd="sng" algn="ctr">
           <a:solidFill>
-            <a:schemeClr val="phClr"/>
+            <a:schemeClr val="phClr">
+              <a:shade val="95000"/>
+              <a:satMod val="105000"/>
+            </a:schemeClr>
           </a:solidFill>
           <a:prstDash val="solid"/>
-          <a:miter lim="800000"/>
-        </a:ln>
-        <a:ln w="19050" cap="flat" cmpd="sng" algn="ctr">
-          <a:solidFill>
-            <a:schemeClr val="phClr"/>
-          </a:solidFill>
-          <a:prstDash val="solid"/>
-          <a:miter lim="800000"/>
         </a:ln>
         <a:ln w="25400" cap="flat" cmpd="sng" algn="ctr">
           <a:solidFill>
             <a:schemeClr val="phClr"/>
           </a:solidFill>
           <a:prstDash val="solid"/>
-          <a:miter lim="800000"/>
+        </a:ln>
+        <a:ln w="38100" cap="flat" cmpd="sng" algn="ctr">
+          <a:solidFill>
+            <a:schemeClr val="phClr"/>
+          </a:solidFill>
+          <a:prstDash val="solid"/>
         </a:ln>
       </a:lnStyleLst>
       <a:effectStyleLst>
         <a:effectStyle>
-          <a:effectLst/>
-        </a:effectStyle>
-        <a:effectStyle>
-          <a:effectLst/>
+          <a:effectLst>
+            <a:outerShdw blurRad="40000" dist="20000" dir="5400000" rotWithShape="0">
+              <a:srgbClr val="000000">
+                <a:alpha val="38000"/>
+              </a:srgbClr>
+            </a:outerShdw>
+          </a:effectLst>
         </a:effectStyle>
         <a:effectStyle>
           <a:effectLst>
-            <a:outerShdw blurRad="57150" dist="19050" dir="5400000" algn="ctr" rotWithShape="0">
+            <a:outerShdw blurRad="40000" dist="23000" dir="5400000" rotWithShape="0">
               <a:srgbClr val="000000">
-                <a:alpha val="63000"/>
+                <a:alpha val="35000"/>
               </a:srgbClr>
             </a:outerShdw>
           </a:effectLst>
+        </a:effectStyle>
+        <a:effectStyle>
+          <a:effectLst>
+            <a:outerShdw blurRad="40000" dist="23000" dir="5400000" rotWithShape="0">
+              <a:srgbClr val="000000">
+                <a:alpha val="35000"/>
+              </a:srgbClr>
+            </a:outerShdw>
+          </a:effectLst>
+          <a:scene3d>
+            <a:camera prst="orthographicFront">
+              <a:rot lat="0" lon="0" rev="0"/>
+            </a:camera>
+            <a:lightRig rig="threePt" dir="t">
+              <a:rot lat="0" lon="0" rev="1200000"/>
+            </a:lightRig>
+          </a:scene3d>
+          <a:sp3d>
+            <a:bevelT w="63500" h="25400"/>
+          </a:sp3d>
         </a:effectStyle>
       </a:effectStyleLst>
       <a:bgFillStyleLst>
         <a:solidFill>
           <a:schemeClr val="phClr"/>
         </a:solidFill>
-        <a:solidFill>
-          <a:schemeClr val="phClr">
-            <a:tint val="95000"/>
-            <a:satMod val="170000"/>
-          </a:schemeClr>
-        </a:solidFill>
         <a:gradFill rotWithShape="1">
           <a:gsLst>
             <a:gs pos="0">
               <a:schemeClr val="phClr">
-                <a:tint val="93000"/>
-                <a:satMod val="150000"/>
-                <a:shade val="98000"/>
-                <a:lumMod val="102000"/>
+                <a:tint val="40000"/>
+                <a:satMod val="350000"/>
               </a:schemeClr>
             </a:gs>
-            <a:gs pos="50000">
+            <a:gs pos="40000">
               <a:schemeClr val="phClr">
-                <a:tint val="98000"/>
-                <a:satMod val="130000"/>
-                <a:shade val="90000"/>
-                <a:lumMod val="103000"/>
+                <a:tint val="45000"/>
+                <a:shade val="99000"/>
+                <a:satMod val="350000"/>
               </a:schemeClr>
             </a:gs>
             <a:gs pos="100000">
               <a:schemeClr val="phClr">
-                <a:shade val="63000"/>
-                <a:satMod val="120000"/>
+                <a:shade val="20000"/>
+                <a:satMod val="255000"/>
               </a:schemeClr>
             </a:gs>
           </a:gsLst>
-          <a:lin ang="5400000" scaled="0"/>
+          <a:path path="circle">
+            <a:fillToRect l="50000" t="-80000" r="50000" b="180000"/>
+          </a:path>
+        </a:gradFill>
+        <a:gradFill rotWithShape="1">
+          <a:gsLst>
+            <a:gs pos="0">
+              <a:schemeClr val="phClr">
+                <a:tint val="80000"/>
+                <a:satMod val="300000"/>
+              </a:schemeClr>
+            </a:gs>
+            <a:gs pos="100000">
+              <a:schemeClr val="phClr">
+                <a:shade val="30000"/>
+                <a:satMod val="200000"/>
+              </a:schemeClr>
+            </a:gs>
+          </a:gsLst>
+          <a:path path="circle">
+            <a:fillToRect l="50000" t="50000" r="50000" b="50000"/>
+          </a:path>
         </a:gradFill>
       </a:bgFillStyleLst>
     </a:fmtScheme>
   </a:themeElements>
   <a:objectDefaults>
+    <a:spDef>
+      <a:spPr/>
+      <a:bodyPr/>
+      <a:lstStyle/>
+      <a:style>
+        <a:lnRef idx="1">
+          <a:schemeClr val="accent1"/>
+        </a:lnRef>
+        <a:fillRef idx="3">
+          <a:schemeClr val="accent1"/>
+        </a:fillRef>
+        <a:effectRef idx="2">
+          <a:schemeClr val="accent1"/>
+        </a:effectRef>
+        <a:fontRef idx="minor">
+          <a:schemeClr val="lt1"/>
+        </a:fontRef>
+      </a:style>
+    </a:spDef>
     <a:lnDef>
       <a:spPr/>
       <a:bodyPr/>
@@ -7676,10 +7733,5 @@
     </a:lnDef>
   </a:objectDefaults>
   <a:extraClrSchemeLst/>
-  <a:extLst>
-    <a:ext uri="{05A4C25C-085E-4340-85A3-A5531E510DB2}">
-      <thm15:themeFamily xmlns:thm15="http://schemas.microsoft.com/office/thememl/2012/main" name="Office Theme" id="{2E142A2C-CD16-42D6-873A-C26D2A0506FA}" vid="{1BDDFF52-6CD6-40A5-AB3C-68EB2F1E4D0A}"/>
-    </a:ext>
-  </a:extLst>
 </a:theme>
 </file>
</xml_diff>